<commit_message>
docs(presentations): avance con Infrastructure Design y notas del presentador
- Diapositiva 2: Infrastructure Design aprobada y Code Generation Parte 1
  en curso (plan de U1 contratos listo, 19 pasos).
- Nuevas diapositivas 7 y 8: dos máquinas con un mismo chart y el camino
  del PR al clúster con aprobación humana (AUTONOMIA-01).
- Menos texto en las diapositivas 1, 3, 5 y 6.
- Notas del presentador en las 8 diapositivas, de 1 minuto cada una.

Co-Authored-By: Claude Opus 5.5 <noreply@anthropic.com>
</commit_message>
<xml_diff>
--- a/presentations/Veridicus_AIDLC_avance.pptx
+++ b/presentations/Veridicus_AIDLC_avance.pptx
@@ -11,6 +11,8 @@
     <p:sldId id="259" r:id="rId5"/>
     <p:sldId id="260" r:id="rId6"/>
     <p:sldId id="261" r:id="rId7"/>
+    <p:sldId id="262" r:id="rId13"/>
+    <p:sldId id="263" r:id="rId14"/>
   </p:sldIdLst>
   <p:notesMasterIdLst>
     <p:notesMasterId r:id="rId8"/>
@@ -541,10 +543,28 @@
           <a:lstStyle/>
           <a:p>
             <a:r>
-              <a:rPr lang="en-US" dirty="0"/>
-              <a:t>Veridicus es el MVP académico de mi trabajo de grado, Diálogos para la Memoria. Apoya al analista de justicia transicional: compara lo que dice el compareciente con un marco documental y, cuando encuentra una incongruencia por encima del umbral, la propone como sugerencia de revisión con su cadena de razonamiento. La decisión siempre es humana y nada sale del clúster local. Hoy muestro cómo se ha especificado con AI-DLC y en qué punto va.</a:t>
-            </a:r>
-            <a:endParaRPr lang="en-US" dirty="0"/>
+              <a:t>Veridicus es el MVP de mi trabajo de grado, Diálogos para la Memoria.</a:t>
+            </a:r>
+          </a:p>
+          <a:p>
+            <a:r>
+              <a:t>Idea en una frase: apoya al analista de justicia transicional comparando lo que dice el compareciente con un marco documental.</a:t>
+            </a:r>
+          </a:p>
+          <a:p>
+            <a:r>
+              <a:t>Recorrer el flujo de la derecha (1 → 4): entra el testimonio, se busca en el marco de verdad, la IA propone una sugerencia con fragmento, cita y razonamiento, y el analista decide.</a:t>
+            </a:r>
+          </a:p>
+          <a:p>
+            <a:r>
+              <a:t>Mensaje clave: la IA nunca dice quién miente y ningún dato sale del clúster.</a:t>
+            </a:r>
+          </a:p>
+          <a:p>
+            <a:r>
+              <a:t>Hoy: cómo va con AI-DLC y, sobre todo, la etapa nueva: Infrastructure Design.</a:t>
+            </a:r>
           </a:p>
         </p:txBody>
       </p:sp>
@@ -629,10 +649,33 @@
           <a:lstStyle/>
           <a:p>
             <a:r>
-              <a:rPr lang="en-US" dirty="0"/>
-              <a:t>La guía del curso usa AI-DLC 1.0.1. Usé la línea 2 (v2.10.0), que cambia tres cosas visibles: Application Design se parte en Domain Design y Contract Design; Workflow Planning cede su lugar a Units Generation y Delivery Planning, obligatorias en el perfil classic; y aparecen Practices Discovery y Refined Mockups. Además, cada etapa pasa por un revisor adversarial y sensores de trazabilidad antes de mi aprobación. Inception corrió una vez; Construction recorre las 10 unidades etapa por etapa. Hoy estamos en Infrastructure Design. El flujo se detiene en el plan de tareas: nunca se aprueba la Parte 2, que escribe el código. Todo corre en un contenedor Docker propio para que mis skills y configuración generales de Claude no se mezclen con las de AI-DLC.</a:t>
-            </a:r>
-            <a:endParaRPr lang="en-US" dirty="0"/>
+              <a:t>Uso AI-DLC 2.10, no la 1.0.1 de la guía. Las etiquetas «v2» marcan las etapas que no existían en la guía.</a:t>
+            </a:r>
+          </a:p>
+          <a:p>
+            <a:r>
+              <a:t>Inception (fila de arriba) se hizo una vez para todo el producto y está aprobada.</a:t>
+            </a:r>
+          </a:p>
+          <a:p>
+            <a:r>
+              <a:t>Construction recorre las 10 unidades etapa por etapa. Novedad de hoy: Infrastructure Design quedó aprobada para las 9 unidades que la necesitan.</a:t>
+            </a:r>
+          </a:p>
+          <a:p>
+            <a:r>
+              <a:t>Ahora estamos en Code Generation, pero solo la Parte 1: el plan de tareas. Ya está el de la primera unidad, U1 contratos: 19 pasos, cada uno con su comando de verificación. El octágono es el ALTO: no se escribe código en este trabajo.</a:t>
+            </a:r>
+          </a:p>
+          <a:p>
+            <a:r>
+              <a:t>Cada etapa pasa por un revisor adversarial y por mi aprobación.</a:t>
+            </a:r>
+          </a:p>
+          <a:p>
+            <a:r>
+              <a:t>Abajo: todo corre en un contenedor aislado y el trabajo solo sale por git push.</a:t>
+            </a:r>
           </a:p>
         </p:txBody>
       </p:sp>
@@ -717,10 +760,28 @@
           <a:lstStyle/>
           <a:p>
             <a:r>
-              <a:rPr lang="en-US" dirty="0"/>
-              <a:t>Refined Mockups dejó siete pantallas en wireframes de texto; esta es la principal, M4. A la izquierda, la transcripción con el estado de cada turno; a la derecha, las sugerencias de revisión con fragmento, cita, ID del documento y razonamiento. Aceptar o editar solo se habilita después de leer el razonamiento. Si la similitud está por debajo del umbral, no hay alerta: aparece el Paquete de Contexto de Traspaso. Detrás de la pantalla: 3 personas, 44 historias con 139 criterios de aceptación, 9 decisiones de arquitectura y 16 contratos. Las cinco reglas AUTONOMIA del PRD viven en la memoria del equipo y bloquean cualquier etapa que no las cumpla; la 03 (sin veredictos) y la 05 (umbral) son las que más moldean esta pantalla.</a:t>
-            </a:r>
-            <a:endParaRPr lang="en-US" dirty="0"/>
+              <a:t>Esta es la pantalla principal (M4), sale de Refined Mockups.</a:t>
+            </a:r>
+          </a:p>
+          <a:p>
+            <a:r>
+              <a:t>Izquierda: la transcripción con el estado de cada turno. Derecha: la sugerencia con fragmento, cita y documento; el analista acepta, edita o descarta.</a:t>
+            </a:r>
+          </a:p>
+          <a:p>
+            <a:r>
+              <a:t>Turno 3: si la similitud está bajo el umbral no hay alerta, solo el Paquete de Contexto de Traspaso.</a:t>
+            </a:r>
+          </a:p>
+          <a:p>
+            <a:r>
+              <a:t>Las cifras resumen Inception: 44 historias, 139 criterios, 9 decisiones de arquitectura y 16 contratos.</a:t>
+            </a:r>
+          </a:p>
+          <a:p>
+            <a:r>
+              <a:t>Abajo, las 5 reglas AUTONOMIA: son bloqueantes en cada etapa.</a:t>
+            </a:r>
           </a:p>
         </p:txBody>
       </p:sp>
@@ -805,10 +866,28 @@
           <a:lstStyle/>
           <a:p>
             <a:r>
-              <a:rPr lang="en-US" dirty="0"/>
-              <a:t>Domain Design definió once componentes. La consola solo habla con ConsoleApi, la fachada que autentica, autoriza y traduce errores. En verde, el dominio: identidad, marco de verdad, sesión, revisión humana y reporte forense. En naranja, la IA, que trabaja de forma asíncrona por colas: SemanticEvaluation aplica primero la guardia del umbral y solo después llama al juez; SpeechProcessing convierte voz y texto. ModelGateway es el único puerto hacia los modelos e IntegrityPolicy escanea el vocabulario prohibido, también en el reporte. El grafo no tiene ciclos: el resultado de una evaluación vuelve por la cola, no como una llamada de vuelta (ADR-002). Todo vive dentro del clúster.</a:t>
-            </a:r>
-            <a:endParaRPr lang="en-US" dirty="0"/>
+              <a:t>Domain Design dejó 11 componentes y ningún ciclo de dependencias.</a:t>
+            </a:r>
+          </a:p>
+          <a:p>
+            <a:r>
+              <a:t>La consola solo habla con ConsoleApi, la fachada que autentica y autoriza.</a:t>
+            </a:r>
+          </a:p>
+          <a:p>
+            <a:r>
+              <a:t>En verde, el dominio. En naranja, la IA, que trabaja por colas: primero la guardia del umbral y solo después el juez.</a:t>
+            </a:r>
+          </a:p>
+          <a:p>
+            <a:r>
+              <a:t>Punteados, los transversales: el vocabulario prohibido y un único puerto hacia los modelos.</a:t>
+            </a:r>
+          </a:p>
+          <a:p>
+            <a:r>
+              <a:t>Todo vive dentro del clúster local.</a:t>
+            </a:r>
           </a:p>
         </p:txBody>
       </p:sp>
@@ -893,10 +972,28 @@
           <a:lstStyle/>
           <a:p>
             <a:r>
-              <a:rPr lang="en-US" dirty="0"/>
-              <a:t>Los once componentes se despliegan en cuatro servicios. session-api es un monolito modular con seis componentes cuyas fronteras vigila import-linter; semantic-agent evalúa con un usuario de base de datos de solo lectura; audio-worker es la voz, que es SHOULD. Datos: PostgreSQL con pgvector sobre CloudNativePG, Redis Streams para las colas y un volumen para los reportes. Los modelos corren dentro del clúster con llama.cpp y GGUF: un juez de 7B cuantizado y embeddings multilingües, todo en CPU; la GPU es solo un perfil opcional. Una NetworkPolicy niega toda salida; el anonimizador sería el único camino hacia fuera y es COULD. La entrega es GitOps: PR con evidencia, imagen en GHCR por SHA y Argo CD con una deploy key de solo lectura. La CI nunca despliega.</a:t>
-            </a:r>
-            <a:endParaRPr lang="en-US" dirty="0"/>
+              <a:t>Los 11 componentes caben en 4 servicios. session-api es un monolito modular; semantic-agent evalúa con permisos de solo lectura.</a:t>
+            </a:r>
+          </a:p>
+          <a:p>
+            <a:r>
+              <a:t>Datos: PostgreSQL con pgvector, Redis para las colas y un volumen para los reportes.</a:t>
+            </a:r>
+          </a:p>
+          <a:p>
+            <a:r>
+              <a:t>Los modelos corren dentro del clúster y en CPU: el juez de 7B, los embeddings y Whisper para la voz.</a:t>
+            </a:r>
+          </a:p>
+          <a:p>
+            <a:r>
+              <a:t>A la derecha, la entrega GitOps: PR con evidencia, imagen por SHA y Argo CD. La CI nunca despliega.</a:t>
+            </a:r>
+          </a:p>
+          <a:p>
+            <a:r>
+              <a:t>Transición: la siguiente etapa decidió dónde corre todo esto.</a:t>
+            </a:r>
           </a:p>
         </p:txBody>
       </p:sp>
@@ -981,10 +1078,28 @@
           <a:lstStyle/>
           <a:p>
             <a:r>
-              <a:rPr lang="en-US" dirty="0"/>
-              <a:t>Units Generation dejó diez unidades y Delivery Planning las ordenó en nueve Bolts, alineados con los módulos 6 a 8 del curso. Antes del primer Bolt hay dos tareas previas: blindar GitHub (main protegida, CI obligatoria, GHCR privado) y preparar el Golden Dataset sintético. B1 a B3 forman la primera rebanada de punta a punta, el flujo de texto, que es la regla del equipo: la voz solo llega cuando el texto funciona. Nada de B8 en adelante empieza hasta cerrar las MUST; el anonimizador solo se construye si se decide usar un modelo externo. Cada unidad sigue las mismas actividades: primero las pruebas de las guardias en rojo, luego cada capa con sus pruebas, la evaluación de IA cuando el PR toca la IA, el PR con la salida de su comando de verificación y la prueba de humo tras desplegar. Los planes de tareas detallados por unidad salen de Code Generation Parte 1, que viene después de Infrastructure Design.</a:t>
-            </a:r>
-            <a:endParaRPr lang="en-US" dirty="0"/>
+              <a:t>Diez unidades ordenadas en Bolts que siguen los módulos 6 a 8 del curso.</a:t>
+            </a:r>
+          </a:p>
+          <a:p>
+            <a:r>
+              <a:t>Antes del primer Bolt: blindar GitHub y preparar el Golden Dataset sintético.</a:t>
+            </a:r>
+          </a:p>
+          <a:p>
+            <a:r>
+              <a:t>B1 a B3 son la primera rebanada de punta a punta: el flujo de texto. La voz llega solo cuando el texto funciona.</a:t>
+            </a:r>
+          </a:p>
+          <a:p>
+            <a:r>
+              <a:t>La línea roja es el corte MUST: lo de la derecha espera.</a:t>
+            </a:r>
+          </a:p>
+          <a:p>
+            <a:r>
+              <a:t>Abajo, las 5 actividades de cada unidad: pruebas guardia en rojo, capa por capa, evaluación de IA, PR con evidencia y humo.</a:t>
+            </a:r>
           </a:p>
         </p:txBody>
       </p:sp>
@@ -1017,6 +1132,181 @@
         <p14:creationId xmlns:p14="http://schemas.microsoft.com/office/powerpoint/2010/main" val="1024086991"/>
       </p:ext>
     </p:extLst>
+  </p:cSld>
+  <p:clrMapOvr>
+    <a:masterClrMapping/>
+  </p:clrMapOvr>
+</p:notes>
+</file>
+
+<file path=ppt/notesSlides/notesSlide7.xml><?xml version="1.0" encoding="utf-8"?>
+<p:notes xmlns:a="http://schemas.openxmlformats.org/drawingml/2006/main" xmlns:p="http://schemas.openxmlformats.org/presentationml/2006/main" xmlns:r="http://schemas.openxmlformats.org/officeDocument/2006/relationships">
+  <p:cSld>
+    <p:spTree>
+      <p:nvGrpSpPr>
+        <p:cNvPr id="1" name=""/>
+        <p:cNvGrpSpPr/>
+        <p:nvPr/>
+      </p:nvGrpSpPr>
+      <p:grpSpPr>
+        <a:xfrm>
+          <a:off x="0" y="0"/>
+          <a:ext cx="0" cy="0"/>
+          <a:chOff x="0" y="0"/>
+          <a:chExt cx="0" cy="0"/>
+        </a:xfrm>
+      </p:grpSpPr>
+      <p:sp>
+        <p:nvSpPr>
+          <p:cNvPr id="2" name="Slide Image Placeholder 1"/>
+          <p:cNvSpPr>
+            <a:spLocks noGrp="1"/>
+          </p:cNvSpPr>
+          <p:nvPr>
+            <p:ph type="sldImg" idx="2"/>
+          </p:nvPr>
+        </p:nvSpPr>
+        <p:spPr/>
+      </p:sp>
+      <p:sp>
+        <p:nvSpPr>
+          <p:cNvPr id="3" name="Notes Placeholder 2"/>
+          <p:cNvSpPr>
+            <a:spLocks noGrp="1"/>
+          </p:cNvSpPr>
+          <p:nvPr>
+            <p:ph type="body" idx="3" sz="quarter"/>
+          </p:nvPr>
+        </p:nvSpPr>
+        <p:spPr/>
+        <p:txBody>
+          <a:bodyPr/>
+          <a:lstStyle/>
+          <a:p>
+            <a:r>
+              <a:t>Infrastructure Design responde dónde y con qué corre todo.</a:t>
+            </a:r>
+          </a:p>
+          <a:p>
+            <a:r>
+              <a:t>Un solo chart de Helm y las mismas imágenes, en dos máquinas con Minikube.</a:t>
+            </a:r>
+          </a:p>
+          <a:p>
+            <a:r>
+              <a:t>Desarrollo: 20 GiB y 10 CPU, todo el sistema en CPU. Demostración: la máquina de 32 GB, con GPU opcional para la evaluación y la demo.</a:t>
+            </a:r>
+          </a:p>
+          <a:p>
+            <a:r>
+              <a:t>Derecha, las guardias: una NetworkPolicy niega toda salida salvo DNS (AUTONOMIA-04); los modelos se montan de solo lectura y se verifican con sha256 antes de arrancar; y los pods corren sin root.</a:t>
+            </a:r>
+          </a:p>
+          <a:p>
+            <a:r>
+              <a:t>Respaldo: un pg_dump manual antes de la sustentación.</a:t>
+            </a:r>
+          </a:p>
+        </p:txBody>
+      </p:sp>
+      <p:sp>
+        <p:nvSpPr>
+          <p:cNvPr id="4" name="Slide Number Placeholder 3"/>
+          <p:cNvSpPr>
+            <a:spLocks noGrp="1"/>
+          </p:cNvSpPr>
+          <p:nvPr>
+            <p:ph type="sldNum" idx="5" sz="quarter"/>
+          </p:nvPr>
+        </p:nvSpPr>
+        <p:spPr/>
+      </p:sp>
+    </p:spTree>
+  </p:cSld>
+  <p:clrMapOvr>
+    <a:masterClrMapping/>
+  </p:clrMapOvr>
+</p:notes>
+</file>
+
+<file path=ppt/notesSlides/notesSlide8.xml><?xml version="1.0" encoding="utf-8"?>
+<p:notes xmlns:a="http://schemas.openxmlformats.org/drawingml/2006/main" xmlns:p="http://schemas.openxmlformats.org/presentationml/2006/main" xmlns:r="http://schemas.openxmlformats.org/officeDocument/2006/relationships">
+  <p:cSld>
+    <p:spTree>
+      <p:nvGrpSpPr>
+        <p:cNvPr id="1" name=""/>
+        <p:cNvGrpSpPr/>
+        <p:nvPr/>
+      </p:nvGrpSpPr>
+      <p:grpSpPr>
+        <a:xfrm>
+          <a:off x="0" y="0"/>
+          <a:ext cx="0" cy="0"/>
+          <a:chOff x="0" y="0"/>
+          <a:chExt cx="0" cy="0"/>
+        </a:xfrm>
+      </p:grpSpPr>
+      <p:sp>
+        <p:nvSpPr>
+          <p:cNvPr id="2" name="Slide Image Placeholder 1"/>
+          <p:cNvSpPr>
+            <a:spLocks noGrp="1"/>
+          </p:cNvSpPr>
+          <p:nvPr>
+            <p:ph type="sldImg" idx="2"/>
+          </p:nvPr>
+        </p:nvSpPr>
+        <p:spPr/>
+      </p:sp>
+      <p:sp>
+        <p:nvSpPr>
+          <p:cNvPr id="3" name="Notes Placeholder 2"/>
+          <p:cNvSpPr>
+            <a:spLocks noGrp="1"/>
+          </p:cNvSpPr>
+          <p:nvPr>
+            <p:ph type="body" idx="3" sz="quarter"/>
+          </p:nvPr>
+        </p:nvSpPr>
+        <p:spPr/>
+        <p:txBody>
+          <a:bodyPr/>
+          <a:lstStyle/>
+          <a:p>
+            <a:r>
+              <a:t>Este es el camino de cualquier cambio de infraestructura.</a:t>
+            </a:r>
+          </a:p>
+          <a:p>
+            <a:r>
+              <a:t>1, todo cambio es un PR con evidencia. 2, la CI valida sin clúster: renderiza el chart, valida esquemas y aplica políticas Kyverno. 3, la fusión en main protegida es la aprobación humana registrada. 4, yo aplico el artefacto fusionado; desde el módulo 8, Argo CD con una llave de solo lectura. 5, prueba de humo; si falla, git revert.</a:t>
+            </a:r>
+          </a:p>
+          <a:p>
+            <a:r>
+              <a:t>La CI no tiene credenciales del clúster: eso cumple AUTONOMIA-01.</a:t>
+            </a:r>
+          </a:p>
+          <a:p>
+            <a:r>
+              <a:t>Cierre: Infrastructure Design quedó aprobada para 9 unidades. Ya arrancó Code Generation Parte 1: el plan de U1 contratos está listo, con 19 pasos y las pruebas de contratos en rojo primero. Siguen los planes de las demás unidades, sin escribir código.</a:t>
+            </a:r>
+          </a:p>
+        </p:txBody>
+      </p:sp>
+      <p:sp>
+        <p:nvSpPr>
+          <p:cNvPr id="4" name="Slide Number Placeholder 3"/>
+          <p:cNvSpPr>
+            <a:spLocks noGrp="1"/>
+          </p:cNvSpPr>
+          <p:nvPr>
+            <p:ph type="sldNum" idx="5" sz="quarter"/>
+          </p:nvPr>
+        </p:nvSpPr>
+        <p:spPr/>
+      </p:sp>
+    </p:spTree>
   </p:cSld>
   <p:clrMapOvr>
     <a:masterClrMapping/>
@@ -1838,7 +2128,7 @@
                   <a:schemeClr val="accent5"/>
                 </a:solidFill>
               </a:rPr>
-              <a:t>MVP que contrasta el testimonio de un compareciente con un marco documental y propone sugerencias de revisión con su razonamiento, nunca veredictos, dentro de un clúster Kubernetes local.</a:t>
+              <a:t>Sugerencias de revisión con su razonamiento. Nunca veredictos. Todo dentro de un clúster local.</a:t>
             </a:r>
             <a:endParaRPr lang="en-US" sz="1600" dirty="0"/>
           </a:p>
@@ -2451,7 +2741,7 @@
                   <a:schemeClr val="tx2"/>
                 </a:solidFill>
               </a:rPr>
-              <a:t>AI-DLC v2.10 en lugar de la v1.0.1 de la guía</a:t>
+              <a:t>AI-DLC v2.10: Inception lista, Construction en curso</a:t>
             </a:r>
             <a:endParaRPr lang="en-US" sz="3200" dirty="0"/>
           </a:p>
@@ -2721,20 +3011,6 @@
             </a:r>
             <a:endParaRPr lang="en-US" sz="1150" dirty="0"/>
           </a:p>
-          <a:p>
-            <a:pPr algn="ctr" indent="0" marL="0">
-              <a:buNone/>
-            </a:pPr>
-            <a:r>
-              <a:rPr lang="en-US" sz="1000" dirty="0">
-                <a:solidFill>
-                  <a:schemeClr val="tx1"/>
-                </a:solidFill>
-              </a:rPr>
-              <a:t>team-practices.md</a:t>
-            </a:r>
-            <a:endParaRPr lang="en-US" sz="1150" dirty="0"/>
-          </a:p>
         </p:txBody>
       </p:sp>
       <p:sp>
@@ -2826,20 +3102,6 @@
             </a:r>
             <a:endParaRPr lang="en-US" sz="1150" dirty="0"/>
           </a:p>
-          <a:p>
-            <a:pPr algn="ctr" indent="0" marL="0">
-              <a:buNone/>
-            </a:pPr>
-            <a:r>
-              <a:rPr lang="en-US" sz="1000" dirty="0">
-                <a:solidFill>
-                  <a:schemeClr val="tx1"/>
-                </a:solidFill>
-              </a:rPr>
-              <a:t>requirements.md</a:t>
-            </a:r>
-            <a:endParaRPr lang="en-US" sz="1150" dirty="0"/>
-          </a:p>
         </p:txBody>
       </p:sp>
       <p:sp>
@@ -2887,20 +3149,6 @@
             </a:r>
             <a:endParaRPr lang="en-US" sz="1150" dirty="0"/>
           </a:p>
-          <a:p>
-            <a:pPr algn="ctr" indent="0" marL="0">
-              <a:buNone/>
-            </a:pPr>
-            <a:r>
-              <a:rPr lang="en-US" sz="1000" dirty="0">
-                <a:solidFill>
-                  <a:schemeClr val="tx1"/>
-                </a:solidFill>
-              </a:rPr>
-              <a:t>stories.md personas.md</a:t>
-            </a:r>
-            <a:endParaRPr lang="en-US" sz="1150" dirty="0"/>
-          </a:p>
         </p:txBody>
       </p:sp>
       <p:sp>
@@ -2948,20 +3196,6 @@
             </a:r>
             <a:endParaRPr lang="en-US" sz="1150" dirty="0"/>
           </a:p>
-          <a:p>
-            <a:pPr algn="ctr" indent="0" marL="0">
-              <a:buNone/>
-            </a:pPr>
-            <a:r>
-              <a:rPr lang="en-US" sz="1000" dirty="0">
-                <a:solidFill>
-                  <a:schemeClr val="tx1"/>
-                </a:solidFill>
-              </a:rPr>
-              <a:t>mockups.md</a:t>
-            </a:r>
-            <a:endParaRPr lang="en-US" sz="1150" dirty="0"/>
-          </a:p>
         </p:txBody>
       </p:sp>
       <p:sp>
@@ -3053,20 +3287,6 @@
             </a:r>
             <a:endParaRPr lang="en-US" sz="1150" dirty="0"/>
           </a:p>
-          <a:p>
-            <a:pPr algn="ctr" indent="0" marL="0">
-              <a:buNone/>
-            </a:pPr>
-            <a:r>
-              <a:rPr lang="en-US" sz="1000" dirty="0">
-                <a:solidFill>
-                  <a:schemeClr val="tx1"/>
-                </a:solidFill>
-              </a:rPr>
-              <a:t>components.md decisions.md</a:t>
-            </a:r>
-            <a:endParaRPr lang="en-US" sz="1150" dirty="0"/>
-          </a:p>
         </p:txBody>
       </p:sp>
       <p:sp>
@@ -3158,20 +3378,6 @@
             </a:r>
             <a:endParaRPr lang="en-US" sz="1150" dirty="0"/>
           </a:p>
-          <a:p>
-            <a:pPr algn="ctr" indent="0" marL="0">
-              <a:buNone/>
-            </a:pPr>
-            <a:r>
-              <a:rPr lang="en-US" sz="1000" dirty="0">
-                <a:solidFill>
-                  <a:schemeClr val="tx1"/>
-                </a:solidFill>
-              </a:rPr>
-              <a:t>unit-of-work.md</a:t>
-            </a:r>
-            <a:endParaRPr lang="en-US" sz="1150" dirty="0"/>
-          </a:p>
         </p:txBody>
       </p:sp>
       <p:sp>
@@ -3219,20 +3425,6 @@
             </a:r>
             <a:endParaRPr lang="en-US" sz="1150" dirty="0"/>
           </a:p>
-          <a:p>
-            <a:pPr algn="ctr" indent="0" marL="0">
-              <a:buNone/>
-            </a:pPr>
-            <a:r>
-              <a:rPr lang="en-US" sz="1000" dirty="0">
-                <a:solidFill>
-                  <a:schemeClr val="tx1"/>
-                </a:solidFill>
-              </a:rPr>
-              <a:t>contract-summary.md</a:t>
-            </a:r>
-            <a:endParaRPr lang="en-US" sz="1150" dirty="0"/>
-          </a:p>
         </p:txBody>
       </p:sp>
       <p:sp>
@@ -3324,20 +3516,6 @@
             </a:r>
             <a:endParaRPr lang="en-US" sz="1150" dirty="0"/>
           </a:p>
-          <a:p>
-            <a:pPr algn="ctr" indent="0" marL="0">
-              <a:buNone/>
-            </a:pPr>
-            <a:r>
-              <a:rPr lang="en-US" sz="1000" dirty="0">
-                <a:solidFill>
-                  <a:schemeClr val="tx1"/>
-                </a:solidFill>
-              </a:rPr>
-              <a:t>bolt-plan.md</a:t>
-            </a:r>
-            <a:endParaRPr lang="en-US" sz="1150" dirty="0"/>
-          </a:p>
         </p:txBody>
       </p:sp>
       <p:sp>
@@ -3465,20 +3643,6 @@
             </a:r>
             <a:endParaRPr lang="en-US" sz="1150" dirty="0"/>
           </a:p>
-          <a:p>
-            <a:pPr algn="ctr" indent="0" marL="0">
-              <a:buNone/>
-            </a:pPr>
-            <a:r>
-              <a:rPr lang="en-US" sz="1000" dirty="0">
-                <a:solidFill>
-                  <a:schemeClr val="tx1"/>
-                </a:solidFill>
-              </a:rPr>
-              <a:t>functional-spec.md</a:t>
-            </a:r>
-            <a:endParaRPr lang="en-US" sz="1150" dirty="0"/>
-          </a:p>
         </p:txBody>
       </p:sp>
       <p:sp>
@@ -3526,20 +3690,6 @@
             </a:r>
             <a:endParaRPr lang="en-US" sz="1150" dirty="0"/>
           </a:p>
-          <a:p>
-            <a:pPr algn="ctr" indent="0" marL="0">
-              <a:buNone/>
-            </a:pPr>
-            <a:r>
-              <a:rPr lang="en-US" sz="1000" dirty="0">
-                <a:solidFill>
-                  <a:schemeClr val="tx1"/>
-                </a:solidFill>
-              </a:rPr>
-              <a:t>tech-stack-decisions.md</a:t>
-            </a:r>
-            <a:endParaRPr lang="en-US" sz="1150" dirty="0"/>
-          </a:p>
         </p:txBody>
       </p:sp>
       <p:sp>
@@ -3587,20 +3737,6 @@
             </a:r>
             <a:endParaRPr lang="en-US" sz="1150" dirty="0"/>
           </a:p>
-          <a:p>
-            <a:pPr algn="ctr" indent="0" marL="0">
-              <a:buNone/>
-            </a:pPr>
-            <a:r>
-              <a:rPr lang="en-US" sz="1000" dirty="0">
-                <a:solidFill>
-                  <a:schemeClr val="tx1"/>
-                </a:solidFill>
-              </a:rPr>
-              <a:t>logical-components.md</a:t>
-            </a:r>
-            <a:endParaRPr lang="en-US" sz="1150" dirty="0"/>
-          </a:p>
         </p:txBody>
       </p:sp>
       <p:sp>
@@ -3620,13 +3756,13 @@
             </a:avLst>
           </a:prstGeom>
           <a:solidFill>
-            <a:schemeClr val="accent2">
+            <a:schemeClr val="accent1">
               <a:alpha val="18000"/>
             </a:schemeClr>
           </a:solidFill>
           <a:ln w="15875">
             <a:solidFill>
-              <a:schemeClr val="accent2"/>
+              <a:schemeClr val="accent1"/>
             </a:solidFill>
             <a:prstDash val="solid"/>
           </a:ln>
@@ -3645,20 +3781,6 @@
                 </a:solidFill>
               </a:rPr>
               <a:t>Infrastructure Design</a:t>
-            </a:r>
-            <a:endParaRPr lang="en-US" sz="1150" dirty="0"/>
-          </a:p>
-          <a:p>
-            <a:pPr algn="ctr" indent="0" marL="0">
-              <a:buNone/>
-            </a:pPr>
-            <a:r>
-              <a:rPr lang="en-US" sz="1000" dirty="0">
-                <a:solidFill>
-                  <a:schemeClr val="tx1"/>
-                </a:solidFill>
-              </a:rPr>
-              <a:t>infrastructure-specification.md</a:t>
             </a:r>
             <a:endParaRPr lang="en-US" sz="1150" dirty="0"/>
           </a:p>
@@ -3681,15 +3803,15 @@
             </a:avLst>
           </a:prstGeom>
           <a:solidFill>
-            <a:schemeClr val="accent5">
-              <a:alpha val="40000"/>
+            <a:schemeClr val="accent2">
+              <a:alpha val="18000"/>
             </a:schemeClr>
           </a:solidFill>
           <a:ln w="15875">
             <a:solidFill>
-              <a:schemeClr val="accent5"/>
-            </a:solidFill>
-            <a:prstDash val="dash"/>
+              <a:schemeClr val="accent2"/>
+            </a:solidFill>
+            <a:prstDash val="solid"/>
           </a:ln>
         </p:spPr>
         <p:txBody>
@@ -3705,7 +3827,7 @@
                   <a:schemeClr val="tx2"/>
                 </a:solidFill>
               </a:rPr>
-              <a:t>Code Generation · Parte 1</a:t>
+              <a:t>Code Generation</a:t>
             </a:r>
             <a:endParaRPr lang="en-US" sz="1150" dirty="0"/>
           </a:p>
@@ -3719,7 +3841,21 @@
                   <a:schemeClr val="tx1"/>
                 </a:solidFill>
               </a:rPr>
-              <a:t>plan de tareas</a:t>
+              <a:t>Parte 1: plan de tareas</a:t>
+            </a:r>
+            <a:endParaRPr lang="en-US" sz="1150" dirty="0"/>
+          </a:p>
+          <a:p>
+            <a:pPr algn="ctr" indent="0" marL="0">
+              <a:buNone/>
+            </a:pPr>
+            <a:r>
+              <a:rPr lang="en-US" sz="1000" dirty="0">
+                <a:solidFill>
+                  <a:schemeClr val="tx1"/>
+                </a:solidFill>
+              </a:rPr>
+              <a:t>U1 listo · 19 pasos</a:t>
             </a:r>
             <a:endParaRPr lang="en-US" sz="1150" dirty="0"/>
           </a:p>
@@ -3861,7 +3997,7 @@
                   <a:schemeClr val="tx1"/>
                 </a:solidFill>
               </a:rPr>
-              <a:t>Revisores adversariales y sensores de trazabilidad; una aprobación humana por etapa</a:t>
+              <a:t>Revisor adversarial y una aprobación humana por etapa</a:t>
             </a:r>
             <a:endParaRPr lang="en-US" sz="1200" dirty="0"/>
           </a:p>
@@ -3933,7 +4069,7 @@
                   <a:schemeClr val="tx2"/>
                 </a:solidFill>
               </a:rPr>
-              <a:t>Contenedor tai-aidlc</a:t>
+              <a:t>Contenedor aislado</a:t>
             </a:r>
             <a:endParaRPr lang="en-US" sz="1600" dirty="0"/>
           </a:p>
@@ -3947,7 +4083,7 @@
                   <a:schemeClr val="accent4"/>
                 </a:solidFill>
               </a:rPr>
-              <a:t>Ubuntu 24.04 · Claude Code · aidlc 2.10.0</a:t>
+              <a:t>Claude Code · aidlc 2.10.0</a:t>
             </a:r>
             <a:endParaRPr lang="en-US" sz="1600" dirty="0"/>
           </a:p>
@@ -4006,7 +4142,7 @@
                   <a:schemeClr val="tx1"/>
                 </a:solidFill>
               </a:rPr>
-              <a:t>mis skills y configuración generales</a:t>
+              <a:t>mi configuración personal</a:t>
             </a:r>
             <a:endParaRPr lang="en-US" sz="1200" dirty="0"/>
           </a:p>
@@ -4065,7 +4201,7 @@
                   <a:schemeClr val="tx1"/>
                 </a:solidFill>
               </a:rPr>
-              <a:t>solo AI-DLC: skills, hooks y memoria del proyecto</a:t>
+              <a:t>solo AI-DLC</a:t>
             </a:r>
             <a:endParaRPr lang="en-US" sz="1200" dirty="0"/>
           </a:p>
@@ -4148,7 +4284,7 @@
                   <a:schemeClr val="tx1"/>
                 </a:solidFill>
               </a:rPr>
-              <a:t>el trabajo vuelve solo por git push</a:t>
+              <a:t>todo vuelve por git push</a:t>
             </a:r>
             <a:endParaRPr lang="en-US" sz="1200" dirty="0"/>
           </a:p>
@@ -4216,7 +4352,7 @@
       </p:sp>
       <p:sp>
         <p:nvSpPr>
-          <p:cNvPr id="25" name="Slide Number Placeholder 0"/>
+          <p:cNvPr id="1001" name="Slide Number Placeholder 0"/>
           <p:cNvSpPr>
             <a:spLocks noGrp="1"/>
           </p:cNvSpPr>
@@ -5282,14 +5418,14 @@
       </p:sp>
       <p:sp>
         <p:nvSpPr>
-          <p:cNvPr id="26" name="Text 24"/>
-          <p:cNvSpPr txBox="1"/>
-          <p:nvPr/>
-        </p:nvSpPr>
-        <p:spPr>
-          <a:xfrm>
-            <a:off x="7726680" y="1371600"/>
-            <a:ext cx="1920240" cy="914400"/>
+          <p:cNvPr id="27" name="Text 25"/>
+          <p:cNvSpPr txBox="1"/>
+          <p:nvPr/>
+        </p:nvSpPr>
+        <p:spPr>
+          <a:xfrm>
+            <a:off x="7726679" y="1371600"/>
+            <a:ext cx="1920240" cy="1417320"/>
           </a:xfrm>
           <a:prstGeom prst="rect">
             <a:avLst/>
@@ -5312,7 +5448,7 @@
                   <a:schemeClr val="accent1"/>
                 </a:solidFill>
               </a:rPr>
-              <a:t>3</a:t>
+              <a:t>44</a:t>
             </a:r>
             <a:endParaRPr lang="en-US" sz="3200" dirty="0"/>
           </a:p>
@@ -5326,7 +5462,7 @@
                   <a:schemeClr val="tx1"/>
                 </a:solidFill>
               </a:rPr>
-              <a:t>personas</a:t>
+              <a:t>historias</a:t>
             </a:r>
             <a:endParaRPr lang="en-US" sz="3200" dirty="0"/>
           </a:p>
@@ -5334,14 +5470,14 @@
       </p:sp>
       <p:sp>
         <p:nvSpPr>
-          <p:cNvPr id="27" name="Text 25"/>
+          <p:cNvPr id="28" name="Text 26"/>
           <p:cNvSpPr txBox="1"/>
           <p:nvPr/>
         </p:nvSpPr>
         <p:spPr>
           <a:xfrm>
             <a:off x="9829800" y="1371600"/>
-            <a:ext cx="1920240" cy="914400"/>
+            <a:ext cx="1920240" cy="1417320"/>
           </a:xfrm>
           <a:prstGeom prst="rect">
             <a:avLst/>
@@ -5364,7 +5500,7 @@
                   <a:schemeClr val="accent1"/>
                 </a:solidFill>
               </a:rPr>
-              <a:t>44</a:t>
+              <a:t>139</a:t>
             </a:r>
             <a:endParaRPr lang="en-US" sz="3200" dirty="0"/>
           </a:p>
@@ -5378,7 +5514,7 @@
                   <a:schemeClr val="tx1"/>
                 </a:solidFill>
               </a:rPr>
-              <a:t>historias</a:t>
+              <a:t>criterios de aceptación</a:t>
             </a:r>
             <a:endParaRPr lang="en-US" sz="3200" dirty="0"/>
           </a:p>
@@ -5386,14 +5522,14 @@
       </p:sp>
       <p:sp>
         <p:nvSpPr>
-          <p:cNvPr id="28" name="Text 26"/>
-          <p:cNvSpPr txBox="1"/>
-          <p:nvPr/>
-        </p:nvSpPr>
-        <p:spPr>
-          <a:xfrm>
-            <a:off x="7726680" y="2468880"/>
-            <a:ext cx="1920240" cy="914400"/>
+          <p:cNvPr id="30" name="Text 28"/>
+          <p:cNvSpPr txBox="1"/>
+          <p:nvPr/>
+        </p:nvSpPr>
+        <p:spPr>
+          <a:xfrm>
+            <a:off x="7726679" y="3017520"/>
+            <a:ext cx="1920240" cy="1417320"/>
           </a:xfrm>
           <a:prstGeom prst="rect">
             <a:avLst/>
@@ -5416,7 +5552,7 @@
                   <a:schemeClr val="accent1"/>
                 </a:solidFill>
               </a:rPr>
-              <a:t>139</a:t>
+              <a:t>9</a:t>
             </a:r>
             <a:endParaRPr lang="en-US" sz="3200" dirty="0"/>
           </a:p>
@@ -5430,163 +5566,7 @@
                   <a:schemeClr val="tx1"/>
                 </a:solidFill>
               </a:rPr>
-              <a:t>criterios de aceptación</a:t>
-            </a:r>
-            <a:endParaRPr lang="en-US" sz="3200" dirty="0"/>
-          </a:p>
-        </p:txBody>
-      </p:sp>
-      <p:sp>
-        <p:nvSpPr>
-          <p:cNvPr id="29" name="Text 27"/>
-          <p:cNvSpPr txBox="1"/>
-          <p:nvPr/>
-        </p:nvSpPr>
-        <p:spPr>
-          <a:xfrm>
-            <a:off x="9829800" y="2468880"/>
-            <a:ext cx="1920240" cy="914400"/>
-          </a:xfrm>
-          <a:prstGeom prst="rect">
-            <a:avLst/>
-          </a:prstGeom>
-          <a:solidFill>
-            <a:schemeClr val="bg2"/>
-          </a:solidFill>
-          <a:ln/>
-        </p:spPr>
-        <p:txBody>
-          <a:bodyPr wrap="square" lIns="0" tIns="101600" rIns="101600" bIns="0" rtlCol="0" anchor="ctr"/>
-          <a:lstStyle/>
-          <a:p>
-            <a:pPr indent="0" marL="0">
-              <a:buNone/>
-            </a:pPr>
-            <a:r>
-              <a:rPr lang="en-US" sz="3200" b="1" dirty="0">
-                <a:solidFill>
-                  <a:schemeClr val="accent1"/>
-                </a:solidFill>
-              </a:rPr>
-              <a:t>7</a:t>
-            </a:r>
-            <a:endParaRPr lang="en-US" sz="3200" dirty="0"/>
-          </a:p>
-          <a:p>
-            <a:pPr indent="0" marL="0">
-              <a:buNone/>
-            </a:pPr>
-            <a:r>
-              <a:rPr lang="en-US" sz="1100" dirty="0">
-                <a:solidFill>
-                  <a:schemeClr val="tx1"/>
-                </a:solidFill>
-              </a:rPr>
-              <a:t>pantallas M0–M6</a:t>
-            </a:r>
-            <a:endParaRPr lang="en-US" sz="3200" dirty="0"/>
-          </a:p>
-        </p:txBody>
-      </p:sp>
-      <p:sp>
-        <p:nvSpPr>
-          <p:cNvPr id="30" name="Text 28"/>
-          <p:cNvSpPr txBox="1"/>
-          <p:nvPr/>
-        </p:nvSpPr>
-        <p:spPr>
-          <a:xfrm>
-            <a:off x="7726680" y="3566160"/>
-            <a:ext cx="1920240" cy="914400"/>
-          </a:xfrm>
-          <a:prstGeom prst="rect">
-            <a:avLst/>
-          </a:prstGeom>
-          <a:solidFill>
-            <a:schemeClr val="bg2"/>
-          </a:solidFill>
-          <a:ln/>
-        </p:spPr>
-        <p:txBody>
-          <a:bodyPr wrap="square" lIns="0" tIns="101600" rIns="101600" bIns="0" rtlCol="0" anchor="ctr"/>
-          <a:lstStyle/>
-          <a:p>
-            <a:pPr indent="0" marL="0">
-              <a:buNone/>
-            </a:pPr>
-            <a:r>
-              <a:rPr lang="en-US" sz="3200" b="1" dirty="0">
-                <a:solidFill>
-                  <a:schemeClr val="accent1"/>
-                </a:solidFill>
-              </a:rPr>
-              <a:t>9</a:t>
-            </a:r>
-            <a:endParaRPr lang="en-US" sz="3200" dirty="0"/>
-          </a:p>
-          <a:p>
-            <a:pPr indent="0" marL="0">
-              <a:buNone/>
-            </a:pPr>
-            <a:r>
-              <a:rPr lang="en-US" sz="1100" dirty="0">
-                <a:solidFill>
-                  <a:schemeClr val="tx1"/>
-                </a:solidFill>
-              </a:rPr>
               <a:t>decisiones de arquitectura</a:t>
-            </a:r>
-            <a:endParaRPr lang="en-US" sz="3200" dirty="0"/>
-          </a:p>
-        </p:txBody>
-      </p:sp>
-      <p:sp>
-        <p:nvSpPr>
-          <p:cNvPr id="31" name="Text 29"/>
-          <p:cNvSpPr txBox="1"/>
-          <p:nvPr/>
-        </p:nvSpPr>
-        <p:spPr>
-          <a:xfrm>
-            <a:off x="9829800" y="3566160"/>
-            <a:ext cx="1920240" cy="914400"/>
-          </a:xfrm>
-          <a:prstGeom prst="rect">
-            <a:avLst/>
-          </a:prstGeom>
-          <a:solidFill>
-            <a:schemeClr val="bg2"/>
-          </a:solidFill>
-          <a:ln/>
-        </p:spPr>
-        <p:txBody>
-          <a:bodyPr wrap="square" lIns="0" tIns="101600" rIns="101600" bIns="0" rtlCol="0" anchor="ctr"/>
-          <a:lstStyle/>
-          <a:p>
-            <a:pPr indent="0" marL="0">
-              <a:buNone/>
-            </a:pPr>
-            <a:r>
-              <a:rPr lang="en-US" sz="3200" b="1" dirty="0">
-                <a:solidFill>
-                  <a:schemeClr val="accent1"/>
-                </a:solidFill>
-              </a:rPr>
-              <a:t>16</a:t>
-            </a:r>
-            <a:endParaRPr lang="en-US" sz="3200" dirty="0"/>
-          </a:p>
-          <a:p>
-            <a:pPr indent="0" marL="0">
-              <a:buNone/>
-            </a:pPr>
-            <a:r>
-              <a:rPr lang="en-US" sz="1100" dirty="0">
-                <a:solidFill>
-                  <a:schemeClr val="tx1"/>
-                </a:solidFill>
-              </a:rPr>
-              <a:t>contratos entre unidades</a:t>
             </a:r>
             <a:endParaRPr lang="en-US" sz="3200" dirty="0"/>
           </a:p>
@@ -6030,7 +6010,7 @@
       </p:sp>
       <p:sp>
         <p:nvSpPr>
-          <p:cNvPr id="25" name="Slide Number Placeholder 0"/>
+          <p:cNvPr id="1001" name="Slide Number Placeholder 0"/>
           <p:cNvSpPr>
             <a:spLocks noGrp="1"/>
           </p:cNvSpPr>
@@ -6070,6 +6050,58 @@
               <a:t>3</a:t>
             </a:fld>
             <a:endParaRPr lang="en-US"/>
+          </a:p>
+        </p:txBody>
+      </p:sp>
+      <p:sp>
+        <p:nvSpPr>
+          <p:cNvPr id="1002" name="Text 28"/>
+          <p:cNvSpPr txBox="1"/>
+          <p:nvPr/>
+        </p:nvSpPr>
+        <p:spPr>
+          <a:xfrm>
+            <a:off x="9829800" y="3017520"/>
+            <a:ext cx="1920240" cy="1417320"/>
+          </a:xfrm>
+          <a:prstGeom prst="rect">
+            <a:avLst/>
+          </a:prstGeom>
+          <a:solidFill>
+            <a:schemeClr val="bg2"/>
+          </a:solidFill>
+          <a:ln/>
+        </p:spPr>
+        <p:txBody>
+          <a:bodyPr wrap="square" lIns="0" tIns="101600" rIns="101600" bIns="0" rtlCol="0" anchor="ctr"/>
+          <a:lstStyle/>
+          <a:p>
+            <a:pPr indent="0" marL="0">
+              <a:buNone/>
+            </a:pPr>
+            <a:r>
+              <a:rPr lang="en-US" sz="3200" b="1" dirty="0">
+                <a:solidFill>
+                  <a:schemeClr val="accent1"/>
+                </a:solidFill>
+              </a:rPr>
+              <a:t>16</a:t>
+            </a:r>
+            <a:endParaRPr lang="en-US" sz="3200" dirty="0"/>
+          </a:p>
+          <a:p>
+            <a:pPr indent="0" marL="0">
+              <a:buNone/>
+            </a:pPr>
+            <a:r>
+              <a:rPr lang="en-US" sz="1100" dirty="0">
+                <a:solidFill>
+                  <a:schemeClr val="tx1"/>
+                </a:solidFill>
+              </a:rPr>
+              <a:t>contratos entre unidades</a:t>
+            </a:r>
+            <a:endParaRPr lang="en-US" sz="3200" dirty="0"/>
           </a:p>
         </p:txBody>
       </p:sp>
@@ -7467,7 +7499,7 @@
       </p:sp>
       <p:sp>
         <p:nvSpPr>
-          <p:cNvPr id="25" name="Slide Number Placeholder 0"/>
+          <p:cNvPr id="1001" name="Slide Number Placeholder 0"/>
           <p:cNvSpPr>
             <a:spLocks noGrp="1"/>
           </p:cNvSpPr>
@@ -7769,7 +7801,7 @@
                   <a:schemeClr val="tx1"/>
                 </a:solidFill>
               </a:rPr>
-              <a:t>Python 3.12 · monolito modular (6 componentes)</a:t>
+              <a:t>monolito modular</a:t>
             </a:r>
             <a:endParaRPr lang="en-US" sz="1300" dirty="0"/>
           </a:p>
@@ -7829,7 +7861,7 @@
                   <a:schemeClr val="tx1"/>
                 </a:solidFill>
               </a:rPr>
-              <a:t>guardia + juez · BD solo lectura</a:t>
+              <a:t>guardia + juez</a:t>
             </a:r>
             <a:endParaRPr lang="en-US" sz="1300" dirty="0"/>
           </a:p>
@@ -7971,7 +8003,7 @@
                   <a:schemeClr val="accent5"/>
                 </a:solidFill>
               </a:rPr>
-              <a:t>CloudNativePG · pasajes y vectores</a:t>
+              <a:t>CloudNativePG</a:t>
             </a:r>
             <a:endParaRPr lang="en-US" sz="1300" dirty="0"/>
           </a:p>
@@ -8029,7 +8061,7 @@
                   <a:schemeClr val="accent5"/>
                 </a:solidFill>
               </a:rPr>
-              <a:t>colas de turnos y audio</a:t>
+              <a:t>colas</a:t>
             </a:r>
             <a:endParaRPr lang="en-US" sz="1300" dirty="0"/>
           </a:p>
@@ -8087,7 +8119,7 @@
                   <a:schemeClr val="accent5"/>
                 </a:solidFill>
               </a:rPr>
-              <a:t>reportes consolidados</a:t>
+              <a:t>reportes</a:t>
             </a:r>
             <a:endParaRPr lang="en-US" sz="1300" dirty="0"/>
           </a:p>
@@ -8171,7 +8203,7 @@
                   <a:schemeClr val="tx1"/>
                 </a:solidFill>
               </a:rPr>
-              <a:t>Qwen2.5-7B Q4 · llama.cpp</a:t>
+              <a:t>Qwen2.5-7B</a:t>
             </a:r>
             <a:endParaRPr lang="en-US" sz="1300" dirty="0"/>
           </a:p>
@@ -8350,7 +8382,7 @@
                   <a:schemeClr val="tx1"/>
                 </a:solidFill>
               </a:rPr>
-              <a:t>único camino hacia fuera (COULD)</a:t>
+              <a:t>única salida (COULD)</a:t>
             </a:r>
             <a:endParaRPr lang="en-US" sz="1300" dirty="0"/>
           </a:p>
@@ -8716,7 +8748,7 @@
                   <a:schemeClr val="tx1"/>
                 </a:solidFill>
               </a:rPr>
-              <a:t>imagen por SHA, nunca latest</a:t>
+              <a:t>imagen por SHA</a:t>
             </a:r>
             <a:endParaRPr lang="en-US" sz="1300" dirty="0"/>
           </a:p>
@@ -8798,7 +8830,7 @@
                   <a:schemeClr val="tx1"/>
                 </a:solidFill>
               </a:rPr>
-              <a:t>deploy key de solo lectura</a:t>
+              <a:t>solo lectura</a:t>
             </a:r>
             <a:endParaRPr lang="en-US" sz="1300" dirty="0"/>
           </a:p>
@@ -8830,7 +8862,7 @@
       </p:sp>
       <p:sp>
         <p:nvSpPr>
-          <p:cNvPr id="25" name="Slide Number Placeholder 0"/>
+          <p:cNvPr id="1001" name="Slide Number Placeholder 0"/>
           <p:cNvSpPr>
             <a:spLocks noGrp="1"/>
           </p:cNvSpPr>
@@ -10341,20 +10373,6 @@
             </a:r>
             <a:endParaRPr lang="en-US" sz="1200" dirty="0"/>
           </a:p>
-          <a:p>
-            <a:pPr indent="0" marL="0">
-              <a:buNone/>
-            </a:pPr>
-            <a:r>
-              <a:rPr lang="en-US" sz="1000" dirty="0">
-                <a:solidFill>
-                  <a:schemeClr val="accent4"/>
-                </a:solidFill>
-              </a:rPr>
-              <a:t>AUTONOMIA-03/05 y contratos</a:t>
-            </a:r>
-            <a:endParaRPr lang="en-US" sz="1200" dirty="0"/>
-          </a:p>
         </p:txBody>
       </p:sp>
       <p:sp>
@@ -10433,20 +10451,6 @@
             </a:r>
             <a:endParaRPr lang="en-US" sz="1200" dirty="0"/>
           </a:p>
-          <a:p>
-            <a:pPr indent="0" marL="0">
-              <a:buNone/>
-            </a:pPr>
-            <a:r>
-              <a:rPr lang="en-US" sz="1000" dirty="0">
-                <a:solidFill>
-                  <a:schemeClr val="accent4"/>
-                </a:solidFill>
-              </a:rPr>
-              <a:t>80 % líneas · 100 % ramas guardia</a:t>
-            </a:r>
-            <a:endParaRPr lang="en-US" sz="1200" dirty="0"/>
-          </a:p>
         </p:txBody>
       </p:sp>
       <p:sp>
@@ -10525,20 +10529,6 @@
             </a:r>
             <a:endParaRPr lang="en-US" sz="1200" dirty="0"/>
           </a:p>
-          <a:p>
-            <a:pPr indent="0" marL="0">
-              <a:buNone/>
-            </a:pPr>
-            <a:r>
-              <a:rPr lang="en-US" sz="1000" dirty="0">
-                <a:solidFill>
-                  <a:schemeClr val="accent4"/>
-                </a:solidFill>
-              </a:rPr>
-              <a:t>Golden Dataset, temp. 0</a:t>
-            </a:r>
-            <a:endParaRPr lang="en-US" sz="1200" dirty="0"/>
-          </a:p>
         </p:txBody>
       </p:sp>
       <p:sp>
@@ -10617,20 +10607,6 @@
             </a:r>
             <a:endParaRPr lang="en-US" sz="1200" dirty="0"/>
           </a:p>
-          <a:p>
-            <a:pPr indent="0" marL="0">
-              <a:buNone/>
-            </a:pPr>
-            <a:r>
-              <a:rPr lang="en-US" sz="1000" dirty="0">
-                <a:solidFill>
-                  <a:schemeClr val="accent4"/>
-                </a:solidFill>
-              </a:rPr>
-              <a:t>Verificación: &lt;comando&gt;</a:t>
-            </a:r>
-            <a:endParaRPr lang="en-US" sz="1200" dirty="0"/>
-          </a:p>
         </p:txBody>
       </p:sp>
       <p:sp>
@@ -10709,19 +10685,151 @@
             </a:r>
             <a:endParaRPr lang="en-US" sz="1200" dirty="0"/>
           </a:p>
+        </p:txBody>
+      </p:sp>
+      <p:sp>
+        <p:nvSpPr>
+          <p:cNvPr id="1001" name="Slide Number Placeholder 0"/>
+          <p:cNvSpPr>
+            <a:spLocks noGrp="1"/>
+          </p:cNvSpPr>
+          <p:nvPr>
+            <p:ph type="sldNum" sz="quarter" idx="4294967295"/>
+          </p:nvPr>
+        </p:nvSpPr>
+        <p:spPr>
+          <a:xfrm>
+            <a:off x="11274552" y="6446520"/>
+            <a:ext cx="457200" cy="274320"/>
+          </a:xfrm>
+          <a:prstGeom prst="rect">
+            <a:avLst/>
+          </a:prstGeom>
+          <a:extLst>
+            <a:ext uri="{C572A759-6A51-4108-AA02-DFA0A04FC94B}">
+              <ma14:wrappingTextBoxFlag xmlns:ma14="http://schemas.microsoft.com/office/mac/drawingml/2011/main" val="0"/>
+            </a:ext>
+          </a:extLst>
+        </p:spPr>
+        <p:txBody>
+          <a:bodyPr/>
+          <a:lstStyle>
+            <a:lvl1pPr>
+              <a:defRPr sz="1000">
+                <a:solidFill>
+                  <a:schemeClr val="accent4"/>
+                </a:solidFill>
+              </a:defRPr>
+            </a:lvl1pPr>
+          </a:lstStyle>
+          <a:p>
+            <a:pPr algn="r"/>
+            <a:fld id="{F7021451-1387-4CA6-816F-3879F97B5CBC}" type="slidenum">
+              <a:rPr b="0" lang="en-US"/>
+              <a:t>6</a:t>
+            </a:fld>
+            <a:endParaRPr lang="en-US"/>
+          </a:p>
+        </p:txBody>
+      </p:sp>
+    </p:spTree>
+  </p:cSld>
+  <p:clrMapOvr>
+    <a:masterClrMapping/>
+  </p:clrMapOvr>
+</p:sld>
+</file>
+
+<file path=ppt/slides/slide7.xml><?xml version="1.0" encoding="utf-8"?>
+<p:sld xmlns:a="http://schemas.openxmlformats.org/drawingml/2006/main" xmlns:r="http://schemas.openxmlformats.org/officeDocument/2006/relationships" xmlns:p="http://schemas.openxmlformats.org/presentationml/2006/main">
+  <p:cSld name="Slide 5">
+    <p:spTree>
+      <p:nvGrpSpPr>
+        <p:cNvPr id="1" name=""/>
+        <p:cNvGrpSpPr/>
+        <p:nvPr/>
+      </p:nvGrpSpPr>
+      <p:grpSpPr>
+        <a:xfrm>
+          <a:off x="0" y="0"/>
+          <a:ext cx="0" cy="0"/>
+          <a:chOff x="0" y="0"/>
+          <a:chExt cx="0" cy="0"/>
+        </a:xfrm>
+      </p:grpSpPr>
+      <p:sp>
+        <p:nvSpPr>
+          <p:cNvPr id="2" name="Text 0"/>
+          <p:cNvSpPr/>
+          <p:nvPr>
+            <p:ph idx="100" type="body" hasCustomPrompt="1"/>
+          </p:nvPr>
+        </p:nvSpPr>
+        <p:spPr>
+          <a:xfrm>
+            <a:off x="457200" y="292608"/>
+            <a:ext cx="8229600" cy="292608"/>
+          </a:xfrm>
+          <a:prstGeom prst="rect">
+            <a:avLst/>
+          </a:prstGeom>
+          <a:noFill/>
+          <a:ln/>
+        </p:spPr>
+        <p:txBody>
+          <a:bodyPr wrap="square" lIns="0" tIns="0" rIns="0" bIns="0" rtlCol="0"/>
+          <a:lstStyle/>
           <a:p>
             <a:pPr indent="0" marL="0">
               <a:buNone/>
             </a:pPr>
             <a:r>
-              <a:rPr lang="en-US" sz="1000" dirty="0">
-                <a:solidFill>
-                  <a:schemeClr val="accent4"/>
-                </a:solidFill>
-              </a:rPr>
-              <a:t>scripts/smoke.sh</a:t>
+              <a:rPr lang="en-US" sz="1200" b="1" spc="300" kern="0" dirty="0">
+                <a:solidFill>
+                  <a:schemeClr val="accent1"/>
+                </a:solidFill>
+              </a:rPr>
+              <a:t>INFRASTRUCTURE DESIGN</a:t>
             </a:r>
             <a:endParaRPr lang="en-US" sz="1200" dirty="0"/>
+          </a:p>
+        </p:txBody>
+      </p:sp>
+      <p:sp>
+        <p:nvSpPr>
+          <p:cNvPr id="3" name="Text 0"/>
+          <p:cNvSpPr/>
+          <p:nvPr>
+            <p:ph idx="101" type="title" hasCustomPrompt="1"/>
+          </p:nvPr>
+        </p:nvSpPr>
+        <p:spPr>
+          <a:xfrm>
+            <a:off x="457200" y="566928"/>
+            <a:ext cx="11247120" cy="640080"/>
+          </a:xfrm>
+          <a:prstGeom prst="rect">
+            <a:avLst/>
+          </a:prstGeom>
+          <a:noFill/>
+          <a:ln/>
+        </p:spPr>
+        <p:txBody>
+          <a:bodyPr wrap="square" lIns="0" tIns="0" rIns="0" bIns="0" rtlCol="0" anchor="t"/>
+          <a:lstStyle/>
+          <a:p>
+            <a:pPr indent="0" marL="0">
+              <a:buNone/>
+            </a:pPr>
+            <a:r>
+              <a:rPr lang="en-US" sz="3200" b="1" dirty="0">
+                <a:solidFill>
+                  <a:schemeClr val="tx2"/>
+                </a:solidFill>
+              </a:rPr>
+              <a:t>Dos máquinas, un mismo chart</a:t>
+            </a:r>
+            <a:endParaRPr lang="en-US" sz="3200" dirty="0"/>
           </a:p>
         </p:txBody>
       </p:sp>
@@ -10764,9 +10872,1407 @@
             <a:pPr algn="r"/>
             <a:fld id="{F7021451-1387-4CA6-816F-3879F97B5CBC}" type="slidenum">
               <a:rPr b="0" lang="en-US"/>
-              <a:t>6</a:t>
+              <a:t>5</a:t>
             </a:fld>
             <a:endParaRPr lang="en-US"/>
+          </a:p>
+        </p:txBody>
+      </p:sp>
+      <p:sp>
+        <p:nvSpPr>
+          <p:cNvPr id="10" name="Text 8"/>
+          <p:cNvSpPr txBox="1"/>
+          <p:nvPr/>
+        </p:nvSpPr>
+        <p:spPr>
+          <a:xfrm>
+            <a:off x="457200" y="1417320"/>
+            <a:ext cx="6949440" cy="868680"/>
+          </a:xfrm>
+          <a:prstGeom prst="roundRect">
+            <a:avLst>
+              <a:gd name="adj" fmla="val 6957"/>
+            </a:avLst>
+          </a:prstGeom>
+          <a:solidFill>
+            <a:schemeClr val="accent3"/>
+          </a:solidFill>
+          <a:ln>
+            <a:solidFill>
+              <a:schemeClr val="accent3"/>
+            </a:solidFill>
+          </a:ln>
+        </p:spPr>
+        <p:txBody>
+          <a:bodyPr wrap="square" lIns="50800" tIns="76200" rIns="76200" bIns="50800" rtlCol="0" anchor="ctr"/>
+          <a:lstStyle/>
+          <a:p>
+            <a:pPr algn="ctr" indent="0" marL="0">
+              <a:buNone/>
+            </a:pPr>
+            <a:r>
+              <a:rPr lang="en-US" sz="1800" b="1" dirty="0">
+                <a:solidFill>
+                  <a:schemeClr val="bg1"/>
+                </a:solidFill>
+              </a:rPr>
+              <a:t>Chart Helm  deploy/veridicus</a:t>
+            </a:r>
+            <a:endParaRPr lang="en-US" sz="1800" dirty="0"/>
+          </a:p>
+          <a:p>
+            <a:pPr algn="ctr" indent="0" marL="0">
+              <a:buNone/>
+            </a:pPr>
+            <a:r>
+              <a:rPr lang="en-US" sz="1200" dirty="0">
+                <a:solidFill>
+                  <a:schemeClr val="accent5"/>
+                </a:solidFill>
+              </a:rPr>
+              <a:t>mismas imágenes de GHCR</a:t>
+            </a:r>
+            <a:endParaRPr lang="en-US" sz="1200" dirty="0"/>
+          </a:p>
+        </p:txBody>
+      </p:sp>
+      <p:sp>
+        <p:nvSpPr>
+          <p:cNvPr id="1001" name="Shape 23"/>
+          <p:cNvSpPr/>
+          <p:nvPr/>
+        </p:nvSpPr>
+        <p:spPr>
+          <a:xfrm>
+            <a:off x="2148840" y="2286000"/>
+            <a:ext cx="0" cy="411480"/>
+          </a:xfrm>
+          <a:prstGeom prst="line">
+            <a:avLst/>
+          </a:prstGeom>
+          <a:noFill/>
+          <a:ln w="15875">
+            <a:solidFill>
+              <a:schemeClr val="tx2"/>
+            </a:solidFill>
+            <a:prstDash val="solid"/>
+            <a:tailEnd type="triangle"/>
+          </a:ln>
+        </p:spPr>
+      </p:sp>
+      <p:sp>
+        <p:nvSpPr>
+          <p:cNvPr id="1002" name="Shape 23"/>
+          <p:cNvSpPr/>
+          <p:nvPr/>
+        </p:nvSpPr>
+        <p:spPr>
+          <a:xfrm>
+            <a:off x="5715000" y="2286000"/>
+            <a:ext cx="0" cy="411480"/>
+          </a:xfrm>
+          <a:prstGeom prst="line">
+            <a:avLst/>
+          </a:prstGeom>
+          <a:noFill/>
+          <a:ln w="15875">
+            <a:solidFill>
+              <a:schemeClr val="tx2"/>
+            </a:solidFill>
+            <a:prstDash val="solid"/>
+            <a:tailEnd type="triangle"/>
+          </a:ln>
+        </p:spPr>
+      </p:sp>
+      <p:sp>
+        <p:nvSpPr>
+          <p:cNvPr id="5" name="Text 3"/>
+          <p:cNvSpPr txBox="1"/>
+          <p:nvPr/>
+        </p:nvSpPr>
+        <p:spPr>
+          <a:xfrm>
+            <a:off x="457200" y="2743200"/>
+            <a:ext cx="3383280" cy="3291840"/>
+          </a:xfrm>
+          <a:prstGeom prst="roundRect">
+            <a:avLst>
+              <a:gd name="adj" fmla="val 6957"/>
+            </a:avLst>
+          </a:prstGeom>
+          <a:solidFill>
+            <a:schemeClr val="accent1">
+              <a:alpha val="20000"/>
+            </a:schemeClr>
+          </a:solidFill>
+          <a:ln w="15875">
+            <a:solidFill>
+              <a:schemeClr val="accent1"/>
+            </a:solidFill>
+          </a:ln>
+        </p:spPr>
+        <p:txBody>
+          <a:bodyPr wrap="square" lIns="50800" tIns="76200" rIns="76200" bIns="50800" rtlCol="0" anchor="ctr"/>
+          <a:lstStyle/>
+          <a:p>
+            <a:pPr algn="ctr" indent="0" marL="0">
+              <a:buNone/>
+            </a:pPr>
+            <a:r>
+              <a:rPr lang="en-US" sz="4400" b="1" dirty="0">
+                <a:solidFill>
+                  <a:schemeClr val="tx2"/>
+                </a:solidFill>
+              </a:rPr>
+              <a:t>20 GiB</a:t>
+            </a:r>
+            <a:endParaRPr lang="en-US" sz="4400" dirty="0"/>
+          </a:p>
+          <a:p>
+            <a:pPr algn="ctr" indent="0" marL="0">
+              <a:buNone/>
+            </a:pPr>
+            <a:r>
+              <a:rPr lang="en-US" sz="1800" dirty="0">
+                <a:solidFill>
+                  <a:schemeClr val="tx1"/>
+                </a:solidFill>
+              </a:rPr>
+              <a:t>Desarrollo</a:t>
+            </a:r>
+            <a:endParaRPr lang="en-US" sz="1800" dirty="0"/>
+          </a:p>
+          <a:p>
+            <a:pPr algn="ctr" indent="0" marL="0">
+              <a:buNone/>
+            </a:pPr>
+            <a:r>
+              <a:rPr lang="en-US" sz="1300" dirty="0">
+                <a:solidFill>
+                  <a:schemeClr val="tx1"/>
+                </a:solidFill>
+              </a:rPr>
+              <a:t>Minikube · 10 CPU</a:t>
+            </a:r>
+            <a:endParaRPr lang="en-US" sz="1300" dirty="0"/>
+          </a:p>
+          <a:p>
+            <a:pPr algn="ctr" indent="0" marL="0">
+              <a:buNone/>
+            </a:pPr>
+            <a:r>
+              <a:rPr lang="en-US" sz="1300" dirty="0">
+                <a:solidFill>
+                  <a:schemeClr val="tx1"/>
+                </a:solidFill>
+              </a:rPr>
+              <a:t>todo en CPU</a:t>
+            </a:r>
+            <a:endParaRPr lang="en-US" sz="1300" dirty="0"/>
+          </a:p>
+        </p:txBody>
+      </p:sp>
+      <p:sp>
+        <p:nvSpPr>
+          <p:cNvPr id="14" name="Text 12"/>
+          <p:cNvSpPr txBox="1"/>
+          <p:nvPr/>
+        </p:nvSpPr>
+        <p:spPr>
+          <a:xfrm>
+            <a:off x="4023360" y="2743200"/>
+            <a:ext cx="3383280" cy="3291840"/>
+          </a:xfrm>
+          <a:prstGeom prst="roundRect">
+            <a:avLst>
+              <a:gd name="adj" fmla="val 6957"/>
+            </a:avLst>
+          </a:prstGeom>
+          <a:solidFill>
+            <a:schemeClr val="accent2">
+              <a:alpha val="20000"/>
+            </a:schemeClr>
+          </a:solidFill>
+          <a:ln w="15875">
+            <a:solidFill>
+              <a:schemeClr val="accent2"/>
+            </a:solidFill>
+          </a:ln>
+        </p:spPr>
+        <p:txBody>
+          <a:bodyPr wrap="square" lIns="50800" tIns="76200" rIns="76200" bIns="50800" rtlCol="0" anchor="ctr"/>
+          <a:lstStyle/>
+          <a:p>
+            <a:pPr algn="ctr" indent="0" marL="0">
+              <a:buNone/>
+            </a:pPr>
+            <a:r>
+              <a:rPr lang="en-US" sz="4400" b="1" dirty="0">
+                <a:solidFill>
+                  <a:schemeClr val="tx2"/>
+                </a:solidFill>
+              </a:rPr>
+              <a:t>28 GiB</a:t>
+            </a:r>
+            <a:endParaRPr lang="en-US" sz="4400" dirty="0"/>
+          </a:p>
+          <a:p>
+            <a:pPr algn="ctr" indent="0" marL="0">
+              <a:buNone/>
+            </a:pPr>
+            <a:r>
+              <a:rPr lang="en-US" sz="1800" dirty="0">
+                <a:solidFill>
+                  <a:schemeClr val="tx1"/>
+                </a:solidFill>
+              </a:rPr>
+              <a:t>Demostración</a:t>
+            </a:r>
+            <a:endParaRPr lang="en-US" sz="1800" dirty="0"/>
+          </a:p>
+          <a:p>
+            <a:pPr algn="ctr" indent="0" marL="0">
+              <a:buNone/>
+            </a:pPr>
+            <a:r>
+              <a:rPr lang="en-US" sz="1300" dirty="0">
+                <a:solidFill>
+                  <a:schemeClr val="tx1"/>
+                </a:solidFill>
+              </a:rPr>
+              <a:t>Minikube · 32 GB</a:t>
+            </a:r>
+            <a:endParaRPr lang="en-US" sz="1300" dirty="0"/>
+          </a:p>
+          <a:p>
+            <a:pPr algn="ctr" indent="0" marL="0">
+              <a:buNone/>
+            </a:pPr>
+            <a:r>
+              <a:rPr lang="en-US" sz="1300" dirty="0">
+                <a:solidFill>
+                  <a:schemeClr val="tx1"/>
+                </a:solidFill>
+              </a:rPr>
+              <a:t>GPU opcional</a:t>
+            </a:r>
+            <a:endParaRPr lang="en-US" sz="1300" dirty="0"/>
+          </a:p>
+        </p:txBody>
+      </p:sp>
+      <p:sp>
+        <p:nvSpPr>
+          <p:cNvPr id="23" name="Text 21"/>
+          <p:cNvSpPr txBox="1"/>
+          <p:nvPr/>
+        </p:nvSpPr>
+        <p:spPr>
+          <a:xfrm>
+            <a:off x="7863840" y="1417320"/>
+            <a:ext cx="3840480" cy="274320"/>
+          </a:xfrm>
+          <a:prstGeom prst="rect">
+            <a:avLst/>
+          </a:prstGeom>
+          <a:noFill/>
+          <a:ln/>
+        </p:spPr>
+        <p:txBody>
+          <a:bodyPr wrap="square" lIns="0" tIns="0" rIns="0" bIns="0" rtlCol="0" anchor="ctr"/>
+          <a:lstStyle/>
+          <a:p>
+            <a:pPr algn="l" indent="0" marL="0">
+              <a:buNone/>
+            </a:pPr>
+            <a:r>
+              <a:rPr lang="en-US" sz="1000" b="1" spc="100" kern="0" dirty="0">
+                <a:solidFill>
+                  <a:schemeClr val="tx2"/>
+                </a:solidFill>
+              </a:rPr>
+              <a:t>GUARDIAS DEL CLÚSTER</a:t>
+            </a:r>
+            <a:endParaRPr lang="en-US" sz="1000" dirty="0"/>
+          </a:p>
+        </p:txBody>
+      </p:sp>
+      <p:sp>
+        <p:nvSpPr>
+          <p:cNvPr id="24" name="Text 22"/>
+          <p:cNvSpPr txBox="1"/>
+          <p:nvPr/>
+        </p:nvSpPr>
+        <p:spPr>
+          <a:xfrm>
+            <a:off x="7863840" y="1828800"/>
+            <a:ext cx="3840480" cy="1188720"/>
+          </a:xfrm>
+          <a:prstGeom prst="roundRect">
+            <a:avLst>
+              <a:gd name="adj" fmla="val 8889"/>
+            </a:avLst>
+          </a:prstGeom>
+          <a:solidFill>
+            <a:schemeClr val="bg1"/>
+          </a:solidFill>
+          <a:ln w="15875">
+            <a:solidFill>
+              <a:schemeClr val="tx2"/>
+            </a:solidFill>
+          </a:ln>
+        </p:spPr>
+        <p:txBody>
+          <a:bodyPr wrap="square" lIns="50800" tIns="76200" rIns="76200" bIns="50800" rtlCol="0" anchor="ctr"/>
+          <a:lstStyle/>
+          <a:p>
+            <a:pPr algn="ctr" indent="0" marL="0">
+              <a:buNone/>
+            </a:pPr>
+            <a:r>
+              <a:rPr lang="en-US" sz="1500" b="1" dirty="0">
+                <a:solidFill>
+                  <a:schemeClr val="tx2"/>
+                </a:solidFill>
+              </a:rPr>
+              <a:t>Red: negar todo</a:t>
+            </a:r>
+            <a:endParaRPr lang="en-US" sz="1500" dirty="0"/>
+          </a:p>
+          <a:p>
+            <a:pPr algn="ctr" indent="0" marL="0">
+              <a:buNone/>
+            </a:pPr>
+            <a:r>
+              <a:rPr lang="en-US" sz="1200" dirty="0">
+                <a:solidFill>
+                  <a:schemeClr val="tx1"/>
+                </a:solidFill>
+              </a:rPr>
+              <a:t>solo DNS · Calico la hace cumplir</a:t>
+            </a:r>
+            <a:endParaRPr lang="en-US" sz="1200" dirty="0"/>
+          </a:p>
+        </p:txBody>
+      </p:sp>
+      <p:sp>
+        <p:nvSpPr>
+          <p:cNvPr id="1003" name="Text 22"/>
+          <p:cNvSpPr txBox="1"/>
+          <p:nvPr/>
+        </p:nvSpPr>
+        <p:spPr>
+          <a:xfrm>
+            <a:off x="7863840" y="3246120"/>
+            <a:ext cx="3840480" cy="1188720"/>
+          </a:xfrm>
+          <a:prstGeom prst="roundRect">
+            <a:avLst>
+              <a:gd name="adj" fmla="val 8889"/>
+            </a:avLst>
+          </a:prstGeom>
+          <a:solidFill>
+            <a:schemeClr val="bg1"/>
+          </a:solidFill>
+          <a:ln w="15875">
+            <a:solidFill>
+              <a:schemeClr val="tx2"/>
+            </a:solidFill>
+          </a:ln>
+        </p:spPr>
+        <p:txBody>
+          <a:bodyPr wrap="square" lIns="50800" tIns="76200" rIns="76200" bIns="50800" rtlCol="0" anchor="ctr"/>
+          <a:lstStyle/>
+          <a:p>
+            <a:pPr algn="ctr" indent="0" marL="0">
+              <a:buNone/>
+            </a:pPr>
+            <a:r>
+              <a:rPr lang="en-US" sz="1500" b="1" dirty="0">
+                <a:solidFill>
+                  <a:schemeClr val="tx2"/>
+                </a:solidFill>
+              </a:rPr>
+              <a:t>Modelos de solo lectura</a:t>
+            </a:r>
+            <a:endParaRPr lang="en-US" sz="1500" dirty="0"/>
+          </a:p>
+          <a:p>
+            <a:pPr algn="ctr" indent="0" marL="0">
+              <a:buNone/>
+            </a:pPr>
+            <a:r>
+              <a:rPr lang="en-US" sz="1200" dirty="0">
+                <a:solidFill>
+                  <a:schemeClr val="tx1"/>
+                </a:solidFill>
+              </a:rPr>
+              <a:t>sha256 verificado al arrancar</a:t>
+            </a:r>
+            <a:endParaRPr lang="en-US" sz="1200" dirty="0"/>
+          </a:p>
+        </p:txBody>
+      </p:sp>
+      <p:sp>
+        <p:nvSpPr>
+          <p:cNvPr id="1004" name="Text 22"/>
+          <p:cNvSpPr txBox="1"/>
+          <p:nvPr/>
+        </p:nvSpPr>
+        <p:spPr>
+          <a:xfrm>
+            <a:off x="7863840" y="4663440"/>
+            <a:ext cx="3840480" cy="1188720"/>
+          </a:xfrm>
+          <a:prstGeom prst="roundRect">
+            <a:avLst>
+              <a:gd name="adj" fmla="val 8889"/>
+            </a:avLst>
+          </a:prstGeom>
+          <a:solidFill>
+            <a:schemeClr val="bg1"/>
+          </a:solidFill>
+          <a:ln w="15875">
+            <a:solidFill>
+              <a:schemeClr val="tx2"/>
+            </a:solidFill>
+          </a:ln>
+        </p:spPr>
+        <p:txBody>
+          <a:bodyPr wrap="square" lIns="50800" tIns="76200" rIns="76200" bIns="50800" rtlCol="0" anchor="ctr"/>
+          <a:lstStyle/>
+          <a:p>
+            <a:pPr algn="ctr" indent="0" marL="0">
+              <a:buNone/>
+            </a:pPr>
+            <a:r>
+              <a:rPr lang="en-US" sz="1500" b="1" dirty="0">
+                <a:solidFill>
+                  <a:schemeClr val="tx2"/>
+                </a:solidFill>
+              </a:rPr>
+              <a:t>Pod Security restricted</a:t>
+            </a:r>
+            <a:endParaRPr lang="en-US" sz="1500" dirty="0"/>
+          </a:p>
+          <a:p>
+            <a:pPr algn="ctr" indent="0" marL="0">
+              <a:buNone/>
+            </a:pPr>
+            <a:r>
+              <a:rPr lang="en-US" sz="1200" dirty="0">
+                <a:solidFill>
+                  <a:schemeClr val="tx1"/>
+                </a:solidFill>
+              </a:rPr>
+              <a:t>sin root · imágenes por digest</a:t>
+            </a:r>
+            <a:endParaRPr lang="en-US" sz="1200" dirty="0"/>
+          </a:p>
+        </p:txBody>
+      </p:sp>
+    </p:spTree>
+  </p:cSld>
+  <p:clrMapOvr>
+    <a:masterClrMapping/>
+  </p:clrMapOvr>
+</p:sld>
+</file>
+
+<file path=ppt/slides/slide8.xml><?xml version="1.0" encoding="utf-8"?>
+<p:sld xmlns:a="http://schemas.openxmlformats.org/drawingml/2006/main" xmlns:r="http://schemas.openxmlformats.org/officeDocument/2006/relationships" xmlns:p="http://schemas.openxmlformats.org/presentationml/2006/main">
+  <p:cSld name="Slide 5">
+    <p:spTree>
+      <p:nvGrpSpPr>
+        <p:cNvPr id="1" name=""/>
+        <p:cNvGrpSpPr/>
+        <p:nvPr/>
+      </p:nvGrpSpPr>
+      <p:grpSpPr>
+        <a:xfrm>
+          <a:off x="0" y="0"/>
+          <a:ext cx="0" cy="0"/>
+          <a:chOff x="0" y="0"/>
+          <a:chExt cx="0" cy="0"/>
+        </a:xfrm>
+      </p:grpSpPr>
+      <p:sp>
+        <p:nvSpPr>
+          <p:cNvPr id="2" name="Text 0"/>
+          <p:cNvSpPr/>
+          <p:nvPr>
+            <p:ph idx="100" type="body" hasCustomPrompt="1"/>
+          </p:nvPr>
+        </p:nvSpPr>
+        <p:spPr>
+          <a:xfrm>
+            <a:off x="457200" y="292608"/>
+            <a:ext cx="8229600" cy="292608"/>
+          </a:xfrm>
+          <a:prstGeom prst="rect">
+            <a:avLst/>
+          </a:prstGeom>
+          <a:noFill/>
+          <a:ln/>
+        </p:spPr>
+        <p:txBody>
+          <a:bodyPr wrap="square" lIns="0" tIns="0" rIns="0" bIns="0" rtlCol="0"/>
+          <a:lstStyle/>
+          <a:p>
+            <a:pPr indent="0" marL="0">
+              <a:buNone/>
+            </a:pPr>
+            <a:r>
+              <a:rPr lang="en-US" sz="1200" b="1" spc="300" kern="0" dirty="0">
+                <a:solidFill>
+                  <a:schemeClr val="accent1"/>
+                </a:solidFill>
+              </a:rPr>
+              <a:t>INFRASTRUCTURE DESIGN</a:t>
+            </a:r>
+            <a:endParaRPr lang="en-US" sz="1200" dirty="0"/>
+          </a:p>
+        </p:txBody>
+      </p:sp>
+      <p:sp>
+        <p:nvSpPr>
+          <p:cNvPr id="3" name="Text 0"/>
+          <p:cNvSpPr/>
+          <p:nvPr>
+            <p:ph idx="101" type="title" hasCustomPrompt="1"/>
+          </p:nvPr>
+        </p:nvSpPr>
+        <p:spPr>
+          <a:xfrm>
+            <a:off x="457200" y="566928"/>
+            <a:ext cx="11247120" cy="640080"/>
+          </a:xfrm>
+          <a:prstGeom prst="rect">
+            <a:avLst/>
+          </a:prstGeom>
+          <a:noFill/>
+          <a:ln/>
+        </p:spPr>
+        <p:txBody>
+          <a:bodyPr wrap="square" lIns="0" tIns="0" rIns="0" bIns="0" rtlCol="0" anchor="t"/>
+          <a:lstStyle/>
+          <a:p>
+            <a:pPr indent="0" marL="0">
+              <a:buNone/>
+            </a:pPr>
+            <a:r>
+              <a:rPr lang="en-US" sz="3200" b="1" dirty="0">
+                <a:solidFill>
+                  <a:schemeClr val="tx2"/>
+                </a:solidFill>
+              </a:rPr>
+              <a:t>Del PR al clúster, siempre con un humano</a:t>
+            </a:r>
+            <a:endParaRPr lang="en-US" sz="3200" dirty="0"/>
+          </a:p>
+        </p:txBody>
+      </p:sp>
+      <p:sp>
+        <p:nvSpPr>
+          <p:cNvPr id="25" name="Slide Number Placeholder 0"/>
+          <p:cNvSpPr>
+            <a:spLocks noGrp="1"/>
+          </p:cNvSpPr>
+          <p:nvPr>
+            <p:ph type="sldNum" sz="quarter" idx="4294967295"/>
+          </p:nvPr>
+        </p:nvSpPr>
+        <p:spPr>
+          <a:xfrm>
+            <a:off x="11274552" y="6446520"/>
+            <a:ext cx="457200" cy="274320"/>
+          </a:xfrm>
+          <a:prstGeom prst="rect">
+            <a:avLst/>
+          </a:prstGeom>
+          <a:extLst>
+            <a:ext uri="{C572A759-6A51-4108-AA02-DFA0A04FC94B}">
+              <ma14:wrappingTextBoxFlag xmlns:ma14="http://schemas.microsoft.com/office/mac/drawingml/2011/main" val="0"/>
+            </a:ext>
+          </a:extLst>
+        </p:spPr>
+        <p:txBody>
+          <a:bodyPr/>
+          <a:lstStyle>
+            <a:lvl1pPr>
+              <a:defRPr sz="1000">
+                <a:solidFill>
+                  <a:schemeClr val="accent4"/>
+                </a:solidFill>
+              </a:defRPr>
+            </a:lvl1pPr>
+          </a:lstStyle>
+          <a:p>
+            <a:pPr algn="r"/>
+            <a:fld id="{F7021451-1387-4CA6-816F-3879F97B5CBC}" type="slidenum">
+              <a:rPr b="0" lang="en-US"/>
+              <a:t>5</a:t>
+            </a:fld>
+            <a:endParaRPr lang="en-US"/>
+          </a:p>
+        </p:txBody>
+      </p:sp>
+      <p:sp>
+        <p:nvSpPr>
+          <p:cNvPr id="24" name="Text 22"/>
+          <p:cNvSpPr txBox="1"/>
+          <p:nvPr/>
+        </p:nvSpPr>
+        <p:spPr>
+          <a:xfrm>
+            <a:off x="457200" y="1783080"/>
+            <a:ext cx="1920240" cy="1554480"/>
+          </a:xfrm>
+          <a:prstGeom prst="roundRect">
+            <a:avLst>
+              <a:gd name="adj" fmla="val 8889"/>
+            </a:avLst>
+          </a:prstGeom>
+          <a:solidFill>
+            <a:schemeClr val="bg1"/>
+          </a:solidFill>
+          <a:ln w="15875">
+            <a:solidFill>
+              <a:schemeClr val="tx2"/>
+            </a:solidFill>
+          </a:ln>
+        </p:spPr>
+        <p:txBody>
+          <a:bodyPr wrap="square" lIns="50800" tIns="76200" rIns="76200" bIns="50800" rtlCol="0" anchor="ctr"/>
+          <a:lstStyle/>
+          <a:p>
+            <a:pPr algn="ctr" indent="0" marL="0">
+              <a:buNone/>
+            </a:pPr>
+            <a:r>
+              <a:rPr lang="en-US" sz="1500" b="1" dirty="0">
+                <a:solidFill>
+                  <a:schemeClr val="tx2"/>
+                </a:solidFill>
+              </a:rPr>
+              <a:t>PR con evidencia</a:t>
+            </a:r>
+            <a:endParaRPr lang="en-US" sz="1500" dirty="0"/>
+          </a:p>
+          <a:p>
+            <a:pPr algn="ctr" indent="0" marL="0">
+              <a:buNone/>
+            </a:pPr>
+            <a:r>
+              <a:rPr lang="en-US" sz="1100" dirty="0">
+                <a:solidFill>
+                  <a:schemeClr val="tx1"/>
+                </a:solidFill>
+              </a:rPr>
+              <a:t>manifiestos y charts</a:t>
+            </a:r>
+            <a:endParaRPr lang="en-US" sz="1100" dirty="0"/>
+          </a:p>
+        </p:txBody>
+      </p:sp>
+      <p:sp>
+        <p:nvSpPr>
+          <p:cNvPr id="34" name="Text 32"/>
+          <p:cNvSpPr txBox="1"/>
+          <p:nvPr/>
+        </p:nvSpPr>
+        <p:spPr>
+          <a:xfrm>
+            <a:off x="1170432" y="1508760"/>
+            <a:ext cx="502920" cy="502920"/>
+          </a:xfrm>
+          <a:prstGeom prst="ellipse">
+            <a:avLst/>
+          </a:prstGeom>
+          <a:solidFill>
+            <a:schemeClr val="tx2"/>
+          </a:solidFill>
+          <a:ln>
+            <a:solidFill>
+              <a:schemeClr val="tx2"/>
+            </a:solidFill>
+          </a:ln>
+        </p:spPr>
+        <p:txBody>
+          <a:bodyPr wrap="square" lIns="0" tIns="0" rIns="0" bIns="0" rtlCol="0" anchor="ctr"/>
+          <a:lstStyle/>
+          <a:p>
+            <a:pPr algn="ctr" indent="0" marL="0">
+              <a:buNone/>
+            </a:pPr>
+            <a:r>
+              <a:rPr lang="en-US" sz="1600" b="1" dirty="0">
+                <a:solidFill>
+                  <a:schemeClr val="bg1"/>
+                </a:solidFill>
+              </a:rPr>
+              <a:t>1</a:t>
+            </a:r>
+            <a:endParaRPr lang="en-US" sz="1600" dirty="0"/>
+          </a:p>
+        </p:txBody>
+      </p:sp>
+      <p:sp>
+        <p:nvSpPr>
+          <p:cNvPr id="29" name="Shape 27"/>
+          <p:cNvSpPr/>
+          <p:nvPr/>
+        </p:nvSpPr>
+        <p:spPr>
+          <a:xfrm>
+            <a:off x="2423160" y="2560320"/>
+            <a:ext cx="320040" cy="0"/>
+          </a:xfrm>
+          <a:prstGeom prst="line">
+            <a:avLst/>
+          </a:prstGeom>
+          <a:noFill/>
+          <a:ln w="19050">
+            <a:solidFill>
+              <a:schemeClr val="tx2"/>
+            </a:solidFill>
+            <a:prstDash val="solid"/>
+            <a:tailEnd type="triangle"/>
+          </a:ln>
+        </p:spPr>
+      </p:sp>
+      <p:sp>
+        <p:nvSpPr>
+          <p:cNvPr id="1001" name="Text 22"/>
+          <p:cNvSpPr txBox="1"/>
+          <p:nvPr/>
+        </p:nvSpPr>
+        <p:spPr>
+          <a:xfrm>
+            <a:off x="2788920" y="1783080"/>
+            <a:ext cx="1920240" cy="1554480"/>
+          </a:xfrm>
+          <a:prstGeom prst="roundRect">
+            <a:avLst>
+              <a:gd name="adj" fmla="val 8889"/>
+            </a:avLst>
+          </a:prstGeom>
+          <a:solidFill>
+            <a:schemeClr val="bg1"/>
+          </a:solidFill>
+          <a:ln w="15875">
+            <a:solidFill>
+              <a:schemeClr val="tx2"/>
+            </a:solidFill>
+          </a:ln>
+        </p:spPr>
+        <p:txBody>
+          <a:bodyPr wrap="square" lIns="50800" tIns="76200" rIns="76200" bIns="50800" rtlCol="0" anchor="ctr"/>
+          <a:lstStyle/>
+          <a:p>
+            <a:pPr algn="ctr" indent="0" marL="0">
+              <a:buNone/>
+            </a:pPr>
+            <a:r>
+              <a:rPr lang="en-US" sz="1500" b="1" dirty="0">
+                <a:solidFill>
+                  <a:schemeClr val="tx2"/>
+                </a:solidFill>
+              </a:rPr>
+              <a:t>CI sin clúster</a:t>
+            </a:r>
+            <a:endParaRPr lang="en-US" sz="1500" dirty="0"/>
+          </a:p>
+          <a:p>
+            <a:pPr algn="ctr" indent="0" marL="0">
+              <a:buNone/>
+            </a:pPr>
+            <a:r>
+              <a:rPr lang="en-US" sz="1100" dirty="0">
+                <a:solidFill>
+                  <a:schemeClr val="tx1"/>
+                </a:solidFill>
+              </a:rPr>
+              <a:t>helm · kubeconform · Kyverno</a:t>
+            </a:r>
+            <a:endParaRPr lang="en-US" sz="1100" dirty="0"/>
+          </a:p>
+        </p:txBody>
+      </p:sp>
+      <p:sp>
+        <p:nvSpPr>
+          <p:cNvPr id="1002" name="Text 32"/>
+          <p:cNvSpPr txBox="1"/>
+          <p:nvPr/>
+        </p:nvSpPr>
+        <p:spPr>
+          <a:xfrm>
+            <a:off x="3502152" y="1508760"/>
+            <a:ext cx="502920" cy="502920"/>
+          </a:xfrm>
+          <a:prstGeom prst="ellipse">
+            <a:avLst/>
+          </a:prstGeom>
+          <a:solidFill>
+            <a:schemeClr val="tx2"/>
+          </a:solidFill>
+          <a:ln>
+            <a:solidFill>
+              <a:schemeClr val="tx2"/>
+            </a:solidFill>
+          </a:ln>
+        </p:spPr>
+        <p:txBody>
+          <a:bodyPr wrap="square" lIns="0" tIns="0" rIns="0" bIns="0" rtlCol="0" anchor="ctr"/>
+          <a:lstStyle/>
+          <a:p>
+            <a:pPr algn="ctr" indent="0" marL="0">
+              <a:buNone/>
+            </a:pPr>
+            <a:r>
+              <a:rPr lang="en-US" sz="1600" b="1" dirty="0">
+                <a:solidFill>
+                  <a:schemeClr val="bg1"/>
+                </a:solidFill>
+              </a:rPr>
+              <a:t>2</a:t>
+            </a:r>
+            <a:endParaRPr lang="en-US" sz="1600" dirty="0"/>
+          </a:p>
+        </p:txBody>
+      </p:sp>
+      <p:sp>
+        <p:nvSpPr>
+          <p:cNvPr id="1003" name="Shape 27"/>
+          <p:cNvSpPr/>
+          <p:nvPr/>
+        </p:nvSpPr>
+        <p:spPr>
+          <a:xfrm>
+            <a:off x="4754880" y="2560320"/>
+            <a:ext cx="320040" cy="0"/>
+          </a:xfrm>
+          <a:prstGeom prst="line">
+            <a:avLst/>
+          </a:prstGeom>
+          <a:noFill/>
+          <a:ln w="19050">
+            <a:solidFill>
+              <a:schemeClr val="tx2"/>
+            </a:solidFill>
+            <a:prstDash val="solid"/>
+            <a:tailEnd type="triangle"/>
+          </a:ln>
+        </p:spPr>
+      </p:sp>
+      <p:sp>
+        <p:nvSpPr>
+          <p:cNvPr id="5" name="Text 3"/>
+          <p:cNvSpPr txBox="1"/>
+          <p:nvPr/>
+        </p:nvSpPr>
+        <p:spPr>
+          <a:xfrm>
+            <a:off x="5120640" y="1783080"/>
+            <a:ext cx="1920240" cy="1554480"/>
+          </a:xfrm>
+          <a:prstGeom prst="roundRect">
+            <a:avLst>
+              <a:gd name="adj" fmla="val 6957"/>
+            </a:avLst>
+          </a:prstGeom>
+          <a:solidFill>
+            <a:schemeClr val="accent1">
+              <a:alpha val="20000"/>
+            </a:schemeClr>
+          </a:solidFill>
+          <a:ln w="15875">
+            <a:solidFill>
+              <a:schemeClr val="accent1"/>
+            </a:solidFill>
+          </a:ln>
+        </p:spPr>
+        <p:txBody>
+          <a:bodyPr wrap="square" lIns="50800" tIns="76200" rIns="76200" bIns="50800" rtlCol="0" anchor="ctr"/>
+          <a:lstStyle/>
+          <a:p>
+            <a:pPr algn="ctr" indent="0" marL="0">
+              <a:buNone/>
+            </a:pPr>
+            <a:r>
+              <a:rPr lang="en-US" sz="1500" b="1" dirty="0">
+                <a:solidFill>
+                  <a:schemeClr val="tx2"/>
+                </a:solidFill>
+              </a:rPr>
+              <a:t>Fusión en main</a:t>
+            </a:r>
+            <a:endParaRPr lang="en-US" sz="1500" dirty="0"/>
+          </a:p>
+          <a:p>
+            <a:pPr algn="ctr" indent="0" marL="0">
+              <a:buNone/>
+            </a:pPr>
+            <a:r>
+              <a:rPr lang="en-US" sz="1100" dirty="0">
+                <a:solidFill>
+                  <a:schemeClr val="tx1"/>
+                </a:solidFill>
+              </a:rPr>
+              <a:t>= aprobación humana</a:t>
+            </a:r>
+            <a:endParaRPr lang="en-US" sz="1100" dirty="0"/>
+          </a:p>
+        </p:txBody>
+      </p:sp>
+      <p:sp>
+        <p:nvSpPr>
+          <p:cNvPr id="1004" name="Text 32"/>
+          <p:cNvSpPr txBox="1"/>
+          <p:nvPr/>
+        </p:nvSpPr>
+        <p:spPr>
+          <a:xfrm>
+            <a:off x="5833872" y="1508760"/>
+            <a:ext cx="502920" cy="502920"/>
+          </a:xfrm>
+          <a:prstGeom prst="ellipse">
+            <a:avLst/>
+          </a:prstGeom>
+          <a:solidFill>
+            <a:schemeClr val="tx2"/>
+          </a:solidFill>
+          <a:ln>
+            <a:solidFill>
+              <a:schemeClr val="tx2"/>
+            </a:solidFill>
+          </a:ln>
+        </p:spPr>
+        <p:txBody>
+          <a:bodyPr wrap="square" lIns="0" tIns="0" rIns="0" bIns="0" rtlCol="0" anchor="ctr"/>
+          <a:lstStyle/>
+          <a:p>
+            <a:pPr algn="ctr" indent="0" marL="0">
+              <a:buNone/>
+            </a:pPr>
+            <a:r>
+              <a:rPr lang="en-US" sz="1600" b="1" dirty="0">
+                <a:solidFill>
+                  <a:schemeClr val="bg1"/>
+                </a:solidFill>
+              </a:rPr>
+              <a:t>3</a:t>
+            </a:r>
+            <a:endParaRPr lang="en-US" sz="1600" dirty="0"/>
+          </a:p>
+        </p:txBody>
+      </p:sp>
+      <p:sp>
+        <p:nvSpPr>
+          <p:cNvPr id="1005" name="Shape 27"/>
+          <p:cNvSpPr/>
+          <p:nvPr/>
+        </p:nvSpPr>
+        <p:spPr>
+          <a:xfrm>
+            <a:off x="7086600" y="2560320"/>
+            <a:ext cx="320040" cy="0"/>
+          </a:xfrm>
+          <a:prstGeom prst="line">
+            <a:avLst/>
+          </a:prstGeom>
+          <a:noFill/>
+          <a:ln w="19050">
+            <a:solidFill>
+              <a:schemeClr val="tx2"/>
+            </a:solidFill>
+            <a:prstDash val="solid"/>
+            <a:tailEnd type="triangle"/>
+          </a:ln>
+        </p:spPr>
+      </p:sp>
+      <p:sp>
+        <p:nvSpPr>
+          <p:cNvPr id="1006" name="Text 22"/>
+          <p:cNvSpPr txBox="1"/>
+          <p:nvPr/>
+        </p:nvSpPr>
+        <p:spPr>
+          <a:xfrm>
+            <a:off x="7452360" y="1783080"/>
+            <a:ext cx="1920240" cy="1554480"/>
+          </a:xfrm>
+          <a:prstGeom prst="roundRect">
+            <a:avLst>
+              <a:gd name="adj" fmla="val 8889"/>
+            </a:avLst>
+          </a:prstGeom>
+          <a:solidFill>
+            <a:schemeClr val="bg1"/>
+          </a:solidFill>
+          <a:ln w="15875">
+            <a:solidFill>
+              <a:schemeClr val="tx2"/>
+            </a:solidFill>
+          </a:ln>
+        </p:spPr>
+        <p:txBody>
+          <a:bodyPr wrap="square" lIns="50800" tIns="76200" rIns="76200" bIns="50800" rtlCol="0" anchor="ctr"/>
+          <a:lstStyle/>
+          <a:p>
+            <a:pPr algn="ctr" indent="0" marL="0">
+              <a:buNone/>
+            </a:pPr>
+            <a:r>
+              <a:rPr lang="en-US" sz="1500" b="1" dirty="0">
+                <a:solidFill>
+                  <a:schemeClr val="tx2"/>
+                </a:solidFill>
+              </a:rPr>
+              <a:t>Humano aplica</a:t>
+            </a:r>
+            <a:endParaRPr lang="en-US" sz="1500" dirty="0"/>
+          </a:p>
+          <a:p>
+            <a:pPr algn="ctr" indent="0" marL="0">
+              <a:buNone/>
+            </a:pPr>
+            <a:r>
+              <a:rPr lang="en-US" sz="1100" dirty="0">
+                <a:solidFill>
+                  <a:schemeClr val="tx1"/>
+                </a:solidFill>
+              </a:rPr>
+              <a:t>Argo CD en el módulo 8</a:t>
+            </a:r>
+            <a:endParaRPr lang="en-US" sz="1100" dirty="0"/>
+          </a:p>
+        </p:txBody>
+      </p:sp>
+      <p:sp>
+        <p:nvSpPr>
+          <p:cNvPr id="1007" name="Text 32"/>
+          <p:cNvSpPr txBox="1"/>
+          <p:nvPr/>
+        </p:nvSpPr>
+        <p:spPr>
+          <a:xfrm>
+            <a:off x="8165592" y="1508760"/>
+            <a:ext cx="502920" cy="502920"/>
+          </a:xfrm>
+          <a:prstGeom prst="ellipse">
+            <a:avLst/>
+          </a:prstGeom>
+          <a:solidFill>
+            <a:schemeClr val="tx2"/>
+          </a:solidFill>
+          <a:ln>
+            <a:solidFill>
+              <a:schemeClr val="tx2"/>
+            </a:solidFill>
+          </a:ln>
+        </p:spPr>
+        <p:txBody>
+          <a:bodyPr wrap="square" lIns="0" tIns="0" rIns="0" bIns="0" rtlCol="0" anchor="ctr"/>
+          <a:lstStyle/>
+          <a:p>
+            <a:pPr algn="ctr" indent="0" marL="0">
+              <a:buNone/>
+            </a:pPr>
+            <a:r>
+              <a:rPr lang="en-US" sz="1600" b="1" dirty="0">
+                <a:solidFill>
+                  <a:schemeClr val="bg1"/>
+                </a:solidFill>
+              </a:rPr>
+              <a:t>4</a:t>
+            </a:r>
+            <a:endParaRPr lang="en-US" sz="1600" dirty="0"/>
+          </a:p>
+        </p:txBody>
+      </p:sp>
+      <p:sp>
+        <p:nvSpPr>
+          <p:cNvPr id="1008" name="Shape 27"/>
+          <p:cNvSpPr/>
+          <p:nvPr/>
+        </p:nvSpPr>
+        <p:spPr>
+          <a:xfrm>
+            <a:off x="9418320" y="2560320"/>
+            <a:ext cx="320040" cy="0"/>
+          </a:xfrm>
+          <a:prstGeom prst="line">
+            <a:avLst/>
+          </a:prstGeom>
+          <a:noFill/>
+          <a:ln w="19050">
+            <a:solidFill>
+              <a:schemeClr val="tx2"/>
+            </a:solidFill>
+            <a:prstDash val="solid"/>
+            <a:tailEnd type="triangle"/>
+          </a:ln>
+        </p:spPr>
+      </p:sp>
+      <p:sp>
+        <p:nvSpPr>
+          <p:cNvPr id="1009" name="Text 22"/>
+          <p:cNvSpPr txBox="1"/>
+          <p:nvPr/>
+        </p:nvSpPr>
+        <p:spPr>
+          <a:xfrm>
+            <a:off x="9784080" y="1783080"/>
+            <a:ext cx="1920240" cy="1554480"/>
+          </a:xfrm>
+          <a:prstGeom prst="roundRect">
+            <a:avLst>
+              <a:gd name="adj" fmla="val 8889"/>
+            </a:avLst>
+          </a:prstGeom>
+          <a:solidFill>
+            <a:schemeClr val="bg1"/>
+          </a:solidFill>
+          <a:ln w="15875">
+            <a:solidFill>
+              <a:schemeClr val="tx2"/>
+            </a:solidFill>
+          </a:ln>
+        </p:spPr>
+        <p:txBody>
+          <a:bodyPr wrap="square" lIns="50800" tIns="76200" rIns="76200" bIns="50800" rtlCol="0" anchor="ctr"/>
+          <a:lstStyle/>
+          <a:p>
+            <a:pPr algn="ctr" indent="0" marL="0">
+              <a:buNone/>
+            </a:pPr>
+            <a:r>
+              <a:rPr lang="en-US" sz="1500" b="1" dirty="0">
+                <a:solidFill>
+                  <a:schemeClr val="tx2"/>
+                </a:solidFill>
+              </a:rPr>
+              <a:t>Prueba de humo</a:t>
+            </a:r>
+            <a:endParaRPr lang="en-US" sz="1500" dirty="0"/>
+          </a:p>
+          <a:p>
+            <a:pPr algn="ctr" indent="0" marL="0">
+              <a:buNone/>
+            </a:pPr>
+            <a:r>
+              <a:rPr lang="en-US" sz="1100" dirty="0">
+                <a:solidFill>
+                  <a:schemeClr val="tx1"/>
+                </a:solidFill>
+              </a:rPr>
+              <a:t>si falla: git revert</a:t>
+            </a:r>
+            <a:endParaRPr lang="en-US" sz="1100" dirty="0"/>
+          </a:p>
+        </p:txBody>
+      </p:sp>
+      <p:sp>
+        <p:nvSpPr>
+          <p:cNvPr id="1010" name="Text 32"/>
+          <p:cNvSpPr txBox="1"/>
+          <p:nvPr/>
+        </p:nvSpPr>
+        <p:spPr>
+          <a:xfrm>
+            <a:off x="10497312" y="1508760"/>
+            <a:ext cx="502920" cy="502920"/>
+          </a:xfrm>
+          <a:prstGeom prst="ellipse">
+            <a:avLst/>
+          </a:prstGeom>
+          <a:solidFill>
+            <a:schemeClr val="tx2"/>
+          </a:solidFill>
+          <a:ln>
+            <a:solidFill>
+              <a:schemeClr val="tx2"/>
+            </a:solidFill>
+          </a:ln>
+        </p:spPr>
+        <p:txBody>
+          <a:bodyPr wrap="square" lIns="0" tIns="0" rIns="0" bIns="0" rtlCol="0" anchor="ctr"/>
+          <a:lstStyle/>
+          <a:p>
+            <a:pPr algn="ctr" indent="0" marL="0">
+              <a:buNone/>
+            </a:pPr>
+            <a:r>
+              <a:rPr lang="en-US" sz="1600" b="1" dirty="0">
+                <a:solidFill>
+                  <a:schemeClr val="bg1"/>
+                </a:solidFill>
+              </a:rPr>
+              <a:t>5</a:t>
+            </a:r>
+            <a:endParaRPr lang="en-US" sz="1600" dirty="0"/>
+          </a:p>
+        </p:txBody>
+      </p:sp>
+      <p:sp>
+        <p:nvSpPr>
+          <p:cNvPr id="30" name="Text 28"/>
+          <p:cNvSpPr txBox="1"/>
+          <p:nvPr/>
+        </p:nvSpPr>
+        <p:spPr>
+          <a:xfrm>
+            <a:off x="457200" y="4069080"/>
+            <a:ext cx="2377440" cy="1463040"/>
+          </a:xfrm>
+          <a:prstGeom prst="rect">
+            <a:avLst/>
+          </a:prstGeom>
+          <a:solidFill>
+            <a:schemeClr val="bg2"/>
+          </a:solidFill>
+          <a:ln/>
+        </p:spPr>
+        <p:txBody>
+          <a:bodyPr wrap="square" lIns="0" tIns="101600" rIns="101600" bIns="0" rtlCol="0" anchor="ctr"/>
+          <a:lstStyle/>
+          <a:p>
+            <a:pPr indent="0" marL="0">
+              <a:buNone/>
+            </a:pPr>
+            <a:r>
+              <a:rPr lang="en-US" sz="3200" b="1" dirty="0">
+                <a:solidFill>
+                  <a:schemeClr val="accent1"/>
+                </a:solidFill>
+              </a:rPr>
+              <a:t>9</a:t>
+            </a:r>
+            <a:endParaRPr lang="en-US" sz="3200" dirty="0"/>
+          </a:p>
+          <a:p>
+            <a:pPr indent="0" marL="0">
+              <a:buNone/>
+            </a:pPr>
+            <a:r>
+              <a:rPr lang="en-US" sz="1100" dirty="0">
+                <a:solidFill>
+                  <a:schemeClr val="tx1"/>
+                </a:solidFill>
+              </a:rPr>
+              <a:t>unidades con infraestructura</a:t>
+            </a:r>
+            <a:endParaRPr lang="en-US" sz="3200" dirty="0"/>
+          </a:p>
+        </p:txBody>
+      </p:sp>
+      <p:sp>
+        <p:nvSpPr>
+          <p:cNvPr id="1011" name="Text 28"/>
+          <p:cNvSpPr txBox="1"/>
+          <p:nvPr/>
+        </p:nvSpPr>
+        <p:spPr>
+          <a:xfrm>
+            <a:off x="3063240" y="4069080"/>
+            <a:ext cx="2377440" cy="1463040"/>
+          </a:xfrm>
+          <a:prstGeom prst="rect">
+            <a:avLst/>
+          </a:prstGeom>
+          <a:solidFill>
+            <a:schemeClr val="bg2"/>
+          </a:solidFill>
+          <a:ln/>
+        </p:spPr>
+        <p:txBody>
+          <a:bodyPr wrap="square" lIns="0" tIns="101600" rIns="101600" bIns="0" rtlCol="0" anchor="ctr"/>
+          <a:lstStyle/>
+          <a:p>
+            <a:pPr indent="0" marL="0">
+              <a:buNone/>
+            </a:pPr>
+            <a:r>
+              <a:rPr lang="en-US" sz="3200" b="1" dirty="0">
+                <a:solidFill>
+                  <a:schemeClr val="accent1"/>
+                </a:solidFill>
+              </a:rPr>
+              <a:t>6</a:t>
+            </a:r>
+            <a:endParaRPr lang="en-US" sz="3200" dirty="0"/>
+          </a:p>
+          <a:p>
+            <a:pPr indent="0" marL="0">
+              <a:buNone/>
+            </a:pPr>
+            <a:r>
+              <a:rPr lang="en-US" sz="1100" dirty="0">
+                <a:solidFill>
+                  <a:schemeClr val="tx1"/>
+                </a:solidFill>
+              </a:rPr>
+              <a:t>puertas offline en la CI</a:t>
+            </a:r>
+            <a:endParaRPr lang="en-US" sz="3200" dirty="0"/>
+          </a:p>
+        </p:txBody>
+      </p:sp>
+      <p:sp>
+        <p:nvSpPr>
+          <p:cNvPr id="1012" name="Text 22"/>
+          <p:cNvSpPr txBox="1"/>
+          <p:nvPr/>
+        </p:nvSpPr>
+        <p:spPr>
+          <a:xfrm>
+            <a:off x="5760720" y="4069080"/>
+            <a:ext cx="5971032" cy="1463040"/>
+          </a:xfrm>
+          <a:prstGeom prst="roundRect">
+            <a:avLst>
+              <a:gd name="adj" fmla="val 8889"/>
+            </a:avLst>
+          </a:prstGeom>
+          <a:solidFill>
+            <a:schemeClr val="bg1"/>
+          </a:solidFill>
+          <a:ln w="15875">
+            <a:solidFill>
+              <a:schemeClr val="tx2"/>
+            </a:solidFill>
+          </a:ln>
+        </p:spPr>
+        <p:txBody>
+          <a:bodyPr wrap="square" lIns="50800" tIns="76200" rIns="76200" bIns="50800" rtlCol="0" anchor="ctr"/>
+          <a:lstStyle/>
+          <a:p>
+            <a:pPr algn="ctr" indent="0" marL="0">
+              <a:buNone/>
+            </a:pPr>
+            <a:r>
+              <a:rPr lang="en-US" sz="1800" b="1" dirty="0">
+                <a:solidFill>
+                  <a:schemeClr val="tx2"/>
+                </a:solidFill>
+              </a:rPr>
+              <a:t>AUTONOMIA-01: la CI no despliega</a:t>
+            </a:r>
+            <a:endParaRPr lang="en-US" sz="1800" dirty="0"/>
+          </a:p>
+          <a:p>
+            <a:pPr algn="ctr" indent="0" marL="0">
+              <a:buNone/>
+            </a:pPr>
+            <a:r>
+              <a:rPr lang="en-US" sz="1300" dirty="0">
+                <a:solidFill>
+                  <a:schemeClr val="tx1"/>
+                </a:solidFill>
+              </a:rPr>
+              <a:t>ningún script aplica cambios al clúster</a:t>
+            </a:r>
+            <a:endParaRPr lang="en-US" sz="1300" dirty="0"/>
           </a:p>
         </p:txBody>
       </p:sp>

</xml_diff>

<commit_message>
docs(presentations): enlace a las maquetas en la diapositiva de Inception
Co-Authored-By: Claude Opus 5.5 <noreply@anthropic.com>
</commit_message>
<xml_diff>
--- a/presentations/Veridicus_AIDLC_avance.pptx
+++ b/presentations/Veridicus_AIDLC_avance.pptx
@@ -760,6 +760,11 @@
           <a:lstStyle/>
           <a:p>
             <a:r>
+              <a:t>Enlace: «Ver las 7 maquetas en línea» abre el artefacto con las pantallas M0–M6 (clic en el enlace o en la maqueta).</a:t>
+            </a:r>
+          </a:p>
+          <a:p>
+            <a:r>
               <a:t>Esta es la pantalla principal (M4), sale de Refined Mockups.</a:t>
             </a:r>
           </a:p>
@@ -4498,7 +4503,9 @@
       </p:sp>
       <p:sp>
         <p:nvSpPr>
-          <p:cNvPr id="4" name="Text 2"/>
+          <p:cNvPr id="4" name="Text 2">
+            <a:hlinkClick r:id="rId3"/>
+          </p:cNvPr>
           <p:cNvSpPr txBox="1"/>
           <p:nvPr/>
         </p:nvSpPr>
@@ -6102,6 +6109,41 @@
               <a:t>contratos entre unidades</a:t>
             </a:r>
             <a:endParaRPr lang="en-US" sz="3200" dirty="0"/>
+          </a:p>
+        </p:txBody>
+      </p:sp>
+      <p:sp>
+        <p:nvSpPr>
+          <p:cNvPr id="43" name="Link maquetas"/>
+          <p:cNvSpPr txBox="1"/>
+          <p:nvPr/>
+        </p:nvSpPr>
+        <p:spPr>
+          <a:xfrm>
+            <a:off x="7726679" y="5943600"/>
+            <a:ext cx="4023360" cy="320040"/>
+          </a:xfrm>
+          <a:prstGeom prst="rect">
+            <a:avLst/>
+          </a:prstGeom>
+          <a:noFill/>
+        </p:spPr>
+        <p:txBody>
+          <a:bodyPr wrap="none" lIns="0" rIns="0">
+            <a:spAutoFit/>
+          </a:bodyPr>
+          <a:lstStyle/>
+          <a:p>
+            <a:pPr algn="r"/>
+            <a:r>
+              <a:rPr sz="1300" b="1">
+                <a:solidFill>
+                  <a:schemeClr val="accent1"/>
+                </a:solidFill>
+                <a:hlinkClick r:id="rId3"/>
+              </a:rPr>
+              <a:t>Ver las 7 maquetas en línea ↗</a:t>
+            </a:r>
           </a:p>
         </p:txBody>
       </p:sp>

</xml_diff>